<commit_message>
Fix text overflow/spacing in pitch deck
Root cause: python-pptx text boxes had no auto-size set (default is
NONE, meaning text silently overflows the box), inherited theme line
spacing (115-120%), and default internal margins eating into space.

Fix: Added _setup_tf() and _setup_p() helpers that apply to every
text box:
- MSO_AUTO_SIZE.TEXT_TO_FIT_SHAPE — PowerPoint auto-shrinks text
  that doesn't fit instead of letting it overflow
- Explicit line_spacing = Pt(fontSize * 1.25) on every paragraph
- Reduced text frame margins (0.04" sides, 0.02" top/bottom)
- space_before = space_after = 0 on all paragraphs

https://claude.ai/code/session_01PtY49K7bv5r2r99EhAAhgg
</commit_message>
<xml_diff>
--- a/MakeItSo_Pitch_Deck.pptx
+++ b/MakeItSo_Pitch_Deck.pptx
@@ -3295,12 +3295,15 @@
           <a:noFill/>
         </p:spPr>
         <p:txBody>
-          <a:bodyPr wrap="square">
-            <a:spAutoFit/>
+          <a:bodyPr wrap="square" lIns="36576" rIns="36576" tIns="18288" bIns="18288">
+            <a:normAutofit/>
           </a:bodyPr>
           <a:lstStyle/>
           <a:p>
             <a:pPr algn="ctr">
+              <a:lnSpc>
+                <a:spcPts val="4500"/>
+              </a:lnSpc>
               <a:spcBef>
                 <a:spcPts val="0"/>
               </a:spcBef>
@@ -3337,12 +3340,15 @@
           <a:noFill/>
         </p:spPr>
         <p:txBody>
-          <a:bodyPr wrap="square">
-            <a:spAutoFit/>
+          <a:bodyPr wrap="square" lIns="36576" rIns="36576" tIns="18288" bIns="18288">
+            <a:normAutofit/>
           </a:bodyPr>
           <a:lstStyle/>
           <a:p>
             <a:pPr algn="ctr">
+              <a:lnSpc>
+                <a:spcPts val="7500"/>
+              </a:lnSpc>
               <a:spcBef>
                 <a:spcPts val="0"/>
               </a:spcBef>
@@ -3379,12 +3385,15 @@
           <a:noFill/>
         </p:spPr>
         <p:txBody>
-          <a:bodyPr wrap="square">
-            <a:spAutoFit/>
+          <a:bodyPr wrap="square" lIns="36576" rIns="36576" tIns="18288" bIns="18288">
+            <a:normAutofit/>
           </a:bodyPr>
           <a:lstStyle/>
           <a:p>
             <a:pPr algn="ctr">
+              <a:lnSpc>
+                <a:spcPts val="2700"/>
+              </a:lnSpc>
               <a:spcBef>
                 <a:spcPts val="0"/>
               </a:spcBef>
@@ -3421,12 +3430,15 @@
           <a:noFill/>
         </p:spPr>
         <p:txBody>
-          <a:bodyPr wrap="square">
-            <a:spAutoFit/>
+          <a:bodyPr wrap="square" lIns="36576" rIns="36576" tIns="18288" bIns="18288">
+            <a:normAutofit/>
           </a:bodyPr>
           <a:lstStyle/>
           <a:p>
             <a:pPr algn="ctr">
+              <a:lnSpc>
+                <a:spcPts val="1700"/>
+              </a:lnSpc>
               <a:spcBef>
                 <a:spcPts val="0"/>
               </a:spcBef>
@@ -3532,12 +3544,15 @@
           <a:noFill/>
         </p:spPr>
         <p:txBody>
-          <a:bodyPr wrap="square">
-            <a:spAutoFit/>
+          <a:bodyPr wrap="square" lIns="36576" rIns="36576" tIns="18288" bIns="18288">
+            <a:normAutofit/>
           </a:bodyPr>
           <a:lstStyle/>
           <a:p>
             <a:pPr algn="l">
+              <a:lnSpc>
+                <a:spcPts val="1600"/>
+              </a:lnSpc>
               <a:spcBef>
                 <a:spcPts val="0"/>
               </a:spcBef>
@@ -3574,12 +3589,15 @@
           <a:noFill/>
         </p:spPr>
         <p:txBody>
-          <a:bodyPr wrap="square">
-            <a:spAutoFit/>
+          <a:bodyPr wrap="square" lIns="36576" rIns="36576" tIns="18288" bIns="18288">
+            <a:normAutofit/>
           </a:bodyPr>
           <a:lstStyle/>
           <a:p>
             <a:pPr algn="l">
+              <a:lnSpc>
+                <a:spcPts val="4700"/>
+              </a:lnSpc>
               <a:spcBef>
                 <a:spcPts val="0"/>
               </a:spcBef>
@@ -3745,12 +3763,15 @@
           <a:noFill/>
         </p:spPr>
         <p:txBody>
-          <a:bodyPr wrap="square">
-            <a:spAutoFit/>
+          <a:bodyPr wrap="square" lIns="36576" rIns="36576" tIns="18288" bIns="18288">
+            <a:normAutofit/>
           </a:bodyPr>
           <a:lstStyle/>
           <a:p>
             <a:pPr algn="ctr">
+              <a:lnSpc>
+                <a:spcPts val="1600"/>
+              </a:lnSpc>
               <a:spcBef>
                 <a:spcPts val="0"/>
               </a:spcBef>
@@ -3787,12 +3808,15 @@
           <a:noFill/>
         </p:spPr>
         <p:txBody>
-          <a:bodyPr wrap="square">
-            <a:spAutoFit/>
+          <a:bodyPr wrap="square" lIns="36576" rIns="36576" tIns="18288" bIns="18288">
+            <a:normAutofit/>
           </a:bodyPr>
           <a:lstStyle/>
           <a:p>
             <a:pPr algn="l">
+              <a:lnSpc>
+                <a:spcPts val="2300"/>
+              </a:lnSpc>
               <a:spcBef>
                 <a:spcPts val="0"/>
               </a:spcBef>
@@ -3829,12 +3853,15 @@
           <a:noFill/>
         </p:spPr>
         <p:txBody>
-          <a:bodyPr wrap="square">
-            <a:spAutoFit/>
+          <a:bodyPr wrap="square" lIns="36576" rIns="36576" tIns="18288" bIns="18288">
+            <a:normAutofit/>
           </a:bodyPr>
           <a:lstStyle/>
           <a:p>
             <a:pPr algn="l">
+              <a:lnSpc>
+                <a:spcPts val="1700"/>
+              </a:lnSpc>
               <a:spcBef>
                 <a:spcPts val="0"/>
               </a:spcBef>
@@ -4000,12 +4027,15 @@
           <a:noFill/>
         </p:spPr>
         <p:txBody>
-          <a:bodyPr wrap="square">
-            <a:spAutoFit/>
+          <a:bodyPr wrap="square" lIns="36576" rIns="36576" tIns="18288" bIns="18288">
+            <a:normAutofit/>
           </a:bodyPr>
           <a:lstStyle/>
           <a:p>
             <a:pPr algn="ctr">
+              <a:lnSpc>
+                <a:spcPts val="1600"/>
+              </a:lnSpc>
               <a:spcBef>
                 <a:spcPts val="0"/>
               </a:spcBef>
@@ -4042,12 +4072,15 @@
           <a:noFill/>
         </p:spPr>
         <p:txBody>
-          <a:bodyPr wrap="square">
-            <a:spAutoFit/>
+          <a:bodyPr wrap="square" lIns="36576" rIns="36576" tIns="18288" bIns="18288">
+            <a:normAutofit/>
           </a:bodyPr>
           <a:lstStyle/>
           <a:p>
             <a:pPr algn="l">
+              <a:lnSpc>
+                <a:spcPts val="2300"/>
+              </a:lnSpc>
               <a:spcBef>
                 <a:spcPts val="0"/>
               </a:spcBef>
@@ -4084,12 +4117,15 @@
           <a:noFill/>
         </p:spPr>
         <p:txBody>
-          <a:bodyPr wrap="square">
-            <a:spAutoFit/>
+          <a:bodyPr wrap="square" lIns="36576" rIns="36576" tIns="18288" bIns="18288">
+            <a:normAutofit/>
           </a:bodyPr>
           <a:lstStyle/>
           <a:p>
             <a:pPr algn="l">
+              <a:lnSpc>
+                <a:spcPts val="1700"/>
+              </a:lnSpc>
               <a:spcBef>
                 <a:spcPts val="0"/>
               </a:spcBef>
@@ -4255,12 +4291,15 @@
           <a:noFill/>
         </p:spPr>
         <p:txBody>
-          <a:bodyPr wrap="square">
-            <a:spAutoFit/>
+          <a:bodyPr wrap="square" lIns="36576" rIns="36576" tIns="18288" bIns="18288">
+            <a:normAutofit/>
           </a:bodyPr>
           <a:lstStyle/>
           <a:p>
             <a:pPr algn="ctr">
+              <a:lnSpc>
+                <a:spcPts val="1600"/>
+              </a:lnSpc>
               <a:spcBef>
                 <a:spcPts val="0"/>
               </a:spcBef>
@@ -4297,12 +4336,15 @@
           <a:noFill/>
         </p:spPr>
         <p:txBody>
-          <a:bodyPr wrap="square">
-            <a:spAutoFit/>
+          <a:bodyPr wrap="square" lIns="36576" rIns="36576" tIns="18288" bIns="18288">
+            <a:normAutofit/>
           </a:bodyPr>
           <a:lstStyle/>
           <a:p>
             <a:pPr algn="l">
+              <a:lnSpc>
+                <a:spcPts val="2300"/>
+              </a:lnSpc>
               <a:spcBef>
                 <a:spcPts val="0"/>
               </a:spcBef>
@@ -4339,12 +4381,15 @@
           <a:noFill/>
         </p:spPr>
         <p:txBody>
-          <a:bodyPr wrap="square">
-            <a:spAutoFit/>
+          <a:bodyPr wrap="square" lIns="36576" rIns="36576" tIns="18288" bIns="18288">
+            <a:normAutofit/>
           </a:bodyPr>
           <a:lstStyle/>
           <a:p>
             <a:pPr algn="l">
+              <a:lnSpc>
+                <a:spcPts val="1700"/>
+              </a:lnSpc>
               <a:spcBef>
                 <a:spcPts val="0"/>
               </a:spcBef>
@@ -4579,12 +4624,15 @@
           <a:noFill/>
         </p:spPr>
         <p:txBody>
-          <a:bodyPr wrap="square">
-            <a:spAutoFit/>
+          <a:bodyPr wrap="square" lIns="36576" rIns="36576" tIns="18288" bIns="18288">
+            <a:normAutofit/>
           </a:bodyPr>
           <a:lstStyle/>
           <a:p>
             <a:pPr algn="ctr">
+              <a:lnSpc>
+                <a:spcPts val="4500"/>
+              </a:lnSpc>
               <a:spcBef>
                 <a:spcPts val="0"/>
               </a:spcBef>
@@ -4621,12 +4669,15 @@
           <a:noFill/>
         </p:spPr>
         <p:txBody>
-          <a:bodyPr wrap="square">
-            <a:spAutoFit/>
+          <a:bodyPr wrap="square" lIns="36576" rIns="36576" tIns="18288" bIns="18288">
+            <a:normAutofit/>
           </a:bodyPr>
           <a:lstStyle/>
           <a:p>
             <a:pPr algn="ctr">
+              <a:lnSpc>
+                <a:spcPts val="5500"/>
+              </a:lnSpc>
               <a:spcBef>
                 <a:spcPts val="0"/>
               </a:spcBef>
@@ -4663,12 +4714,15 @@
           <a:noFill/>
         </p:spPr>
         <p:txBody>
-          <a:bodyPr wrap="square">
-            <a:spAutoFit/>
+          <a:bodyPr wrap="square" lIns="36576" rIns="36576" tIns="18288" bIns="18288">
+            <a:normAutofit/>
           </a:bodyPr>
           <a:lstStyle/>
           <a:p>
             <a:pPr algn="ctr">
+              <a:lnSpc>
+                <a:spcPts val="2200"/>
+              </a:lnSpc>
               <a:spcBef>
                 <a:spcPts val="0"/>
               </a:spcBef>
@@ -4748,12 +4802,15 @@
           <a:noFill/>
         </p:spPr>
         <p:txBody>
-          <a:bodyPr wrap="square">
-            <a:spAutoFit/>
+          <a:bodyPr wrap="square" lIns="36576" rIns="36576" tIns="18288" bIns="18288">
+            <a:normAutofit/>
           </a:bodyPr>
           <a:lstStyle/>
           <a:p>
             <a:pPr algn="ctr">
+              <a:lnSpc>
+                <a:spcPts val="2200"/>
+              </a:lnSpc>
               <a:spcBef>
                 <a:spcPts val="0"/>
               </a:spcBef>
@@ -4790,12 +4847,15 @@
           <a:noFill/>
         </p:spPr>
         <p:txBody>
-          <a:bodyPr wrap="square">
-            <a:spAutoFit/>
+          <a:bodyPr wrap="square" lIns="36576" rIns="36576" tIns="18288" bIns="18288">
+            <a:normAutofit/>
           </a:bodyPr>
           <a:lstStyle/>
           <a:p>
             <a:pPr algn="ctr">
+              <a:lnSpc>
+                <a:spcPts val="1700"/>
+              </a:lnSpc>
               <a:spcBef>
                 <a:spcPts val="0"/>
               </a:spcBef>
@@ -4901,12 +4961,15 @@
           <a:noFill/>
         </p:spPr>
         <p:txBody>
-          <a:bodyPr wrap="square">
-            <a:spAutoFit/>
+          <a:bodyPr wrap="square" lIns="36576" rIns="36576" tIns="18288" bIns="18288">
+            <a:normAutofit/>
           </a:bodyPr>
           <a:lstStyle/>
           <a:p>
             <a:pPr algn="l">
+              <a:lnSpc>
+                <a:spcPts val="1600"/>
+              </a:lnSpc>
               <a:spcBef>
                 <a:spcPts val="0"/>
               </a:spcBef>
@@ -4943,12 +5006,15 @@
           <a:noFill/>
         </p:spPr>
         <p:txBody>
-          <a:bodyPr wrap="square">
-            <a:spAutoFit/>
+          <a:bodyPr wrap="square" lIns="36576" rIns="36576" tIns="18288" bIns="18288">
+            <a:normAutofit/>
           </a:bodyPr>
           <a:lstStyle/>
           <a:p>
             <a:pPr algn="l">
+              <a:lnSpc>
+                <a:spcPts val="4700"/>
+              </a:lnSpc>
               <a:spcBef>
                 <a:spcPts val="0"/>
               </a:spcBef>
@@ -5071,12 +5137,15 @@
           <a:noFill/>
         </p:spPr>
         <p:txBody>
-          <a:bodyPr wrap="square">
-            <a:spAutoFit/>
+          <a:bodyPr wrap="square" lIns="36576" rIns="36576" tIns="18288" bIns="18288">
+            <a:normAutofit/>
           </a:bodyPr>
           <a:lstStyle/>
           <a:p>
             <a:pPr algn="ctr">
+              <a:lnSpc>
+                <a:spcPts val="2700"/>
+              </a:lnSpc>
               <a:spcBef>
                 <a:spcPts val="0"/>
               </a:spcBef>
@@ -5113,12 +5182,15 @@
           <a:noFill/>
         </p:spPr>
         <p:txBody>
-          <a:bodyPr wrap="square">
-            <a:spAutoFit/>
+          <a:bodyPr wrap="square" lIns="36576" rIns="36576" tIns="18288" bIns="18288">
+            <a:normAutofit/>
           </a:bodyPr>
           <a:lstStyle/>
           <a:p>
             <a:pPr algn="ctr">
+              <a:lnSpc>
+                <a:spcPts val="2100"/>
+              </a:lnSpc>
               <a:spcBef>
                 <a:spcPts val="0"/>
               </a:spcBef>
@@ -5155,12 +5227,15 @@
           <a:noFill/>
         </p:spPr>
         <p:txBody>
-          <a:bodyPr wrap="square">
-            <a:spAutoFit/>
+          <a:bodyPr wrap="square" lIns="36576" rIns="36576" tIns="18288" bIns="18288">
+            <a:normAutofit/>
           </a:bodyPr>
           <a:lstStyle/>
           <a:p>
             <a:pPr algn="ctr">
+              <a:lnSpc>
+                <a:spcPts val="1600"/>
+              </a:lnSpc>
               <a:spcBef>
                 <a:spcPts val="0"/>
               </a:spcBef>
@@ -5283,12 +5358,15 @@
           <a:noFill/>
         </p:spPr>
         <p:txBody>
-          <a:bodyPr wrap="square">
-            <a:spAutoFit/>
+          <a:bodyPr wrap="square" lIns="36576" rIns="36576" tIns="18288" bIns="18288">
+            <a:normAutofit/>
           </a:bodyPr>
           <a:lstStyle/>
           <a:p>
             <a:pPr algn="ctr">
+              <a:lnSpc>
+                <a:spcPts val="2700"/>
+              </a:lnSpc>
               <a:spcBef>
                 <a:spcPts val="0"/>
               </a:spcBef>
@@ -5325,12 +5403,15 @@
           <a:noFill/>
         </p:spPr>
         <p:txBody>
-          <a:bodyPr wrap="square">
-            <a:spAutoFit/>
+          <a:bodyPr wrap="square" lIns="36576" rIns="36576" tIns="18288" bIns="18288">
+            <a:normAutofit/>
           </a:bodyPr>
           <a:lstStyle/>
           <a:p>
             <a:pPr algn="ctr">
+              <a:lnSpc>
+                <a:spcPts val="2100"/>
+              </a:lnSpc>
               <a:spcBef>
                 <a:spcPts val="0"/>
               </a:spcBef>
@@ -5367,12 +5448,15 @@
           <a:noFill/>
         </p:spPr>
         <p:txBody>
-          <a:bodyPr wrap="square">
-            <a:spAutoFit/>
+          <a:bodyPr wrap="square" lIns="36576" rIns="36576" tIns="18288" bIns="18288">
+            <a:normAutofit/>
           </a:bodyPr>
           <a:lstStyle/>
           <a:p>
             <a:pPr algn="ctr">
+              <a:lnSpc>
+                <a:spcPts val="1600"/>
+              </a:lnSpc>
               <a:spcBef>
                 <a:spcPts val="0"/>
               </a:spcBef>
@@ -5495,12 +5579,15 @@
           <a:noFill/>
         </p:spPr>
         <p:txBody>
-          <a:bodyPr wrap="square">
-            <a:spAutoFit/>
+          <a:bodyPr wrap="square" lIns="36576" rIns="36576" tIns="18288" bIns="18288">
+            <a:normAutofit/>
           </a:bodyPr>
           <a:lstStyle/>
           <a:p>
             <a:pPr algn="ctr">
+              <a:lnSpc>
+                <a:spcPts val="2700"/>
+              </a:lnSpc>
               <a:spcBef>
                 <a:spcPts val="0"/>
               </a:spcBef>
@@ -5537,12 +5624,15 @@
           <a:noFill/>
         </p:spPr>
         <p:txBody>
-          <a:bodyPr wrap="square">
-            <a:spAutoFit/>
+          <a:bodyPr wrap="square" lIns="36576" rIns="36576" tIns="18288" bIns="18288">
+            <a:normAutofit/>
           </a:bodyPr>
           <a:lstStyle/>
           <a:p>
             <a:pPr algn="ctr">
+              <a:lnSpc>
+                <a:spcPts val="2100"/>
+              </a:lnSpc>
               <a:spcBef>
                 <a:spcPts val="0"/>
               </a:spcBef>
@@ -5579,12 +5669,15 @@
           <a:noFill/>
         </p:spPr>
         <p:txBody>
-          <a:bodyPr wrap="square">
-            <a:spAutoFit/>
+          <a:bodyPr wrap="square" lIns="36576" rIns="36576" tIns="18288" bIns="18288">
+            <a:normAutofit/>
           </a:bodyPr>
           <a:lstStyle/>
           <a:p>
             <a:pPr algn="ctr">
+              <a:lnSpc>
+                <a:spcPts val="1600"/>
+              </a:lnSpc>
               <a:spcBef>
                 <a:spcPts val="0"/>
               </a:spcBef>
@@ -5707,12 +5800,15 @@
           <a:noFill/>
         </p:spPr>
         <p:txBody>
-          <a:bodyPr wrap="square">
-            <a:spAutoFit/>
+          <a:bodyPr wrap="square" lIns="36576" rIns="36576" tIns="18288" bIns="18288">
+            <a:normAutofit/>
           </a:bodyPr>
           <a:lstStyle/>
           <a:p>
             <a:pPr algn="ctr">
+              <a:lnSpc>
+                <a:spcPts val="2700"/>
+              </a:lnSpc>
               <a:spcBef>
                 <a:spcPts val="0"/>
               </a:spcBef>
@@ -5749,12 +5845,15 @@
           <a:noFill/>
         </p:spPr>
         <p:txBody>
-          <a:bodyPr wrap="square">
-            <a:spAutoFit/>
+          <a:bodyPr wrap="square" lIns="36576" rIns="36576" tIns="18288" bIns="18288">
+            <a:normAutofit/>
           </a:bodyPr>
           <a:lstStyle/>
           <a:p>
             <a:pPr algn="ctr">
+              <a:lnSpc>
+                <a:spcPts val="2100"/>
+              </a:lnSpc>
               <a:spcBef>
                 <a:spcPts val="0"/>
               </a:spcBef>
@@ -5791,12 +5890,15 @@
           <a:noFill/>
         </p:spPr>
         <p:txBody>
-          <a:bodyPr wrap="square">
-            <a:spAutoFit/>
+          <a:bodyPr wrap="square" lIns="36576" rIns="36576" tIns="18288" bIns="18288">
+            <a:normAutofit/>
           </a:bodyPr>
           <a:lstStyle/>
           <a:p>
             <a:pPr algn="ctr">
+              <a:lnSpc>
+                <a:spcPts val="1600"/>
+              </a:lnSpc>
               <a:spcBef>
                 <a:spcPts val="0"/>
               </a:spcBef>
@@ -5902,12 +6004,15 @@
           <a:noFill/>
         </p:spPr>
         <p:txBody>
-          <a:bodyPr wrap="square">
-            <a:spAutoFit/>
+          <a:bodyPr wrap="square" lIns="36576" rIns="36576" tIns="18288" bIns="18288">
+            <a:normAutofit/>
           </a:bodyPr>
           <a:lstStyle/>
           <a:p>
             <a:pPr algn="l">
+              <a:lnSpc>
+                <a:spcPts val="1600"/>
+              </a:lnSpc>
               <a:spcBef>
                 <a:spcPts val="0"/>
               </a:spcBef>
@@ -5944,12 +6049,15 @@
           <a:noFill/>
         </p:spPr>
         <p:txBody>
-          <a:bodyPr wrap="square">
-            <a:spAutoFit/>
+          <a:bodyPr wrap="square" lIns="36576" rIns="36576" tIns="18288" bIns="18288">
+            <a:normAutofit/>
           </a:bodyPr>
           <a:lstStyle/>
           <a:p>
             <a:pPr algn="l">
+              <a:lnSpc>
+                <a:spcPts val="4700"/>
+              </a:lnSpc>
               <a:spcBef>
                 <a:spcPts val="0"/>
               </a:spcBef>
@@ -5986,12 +6094,15 @@
           <a:noFill/>
         </p:spPr>
         <p:txBody>
-          <a:bodyPr wrap="square">
-            <a:spAutoFit/>
+          <a:bodyPr wrap="square" lIns="36576" rIns="36576" tIns="18288" bIns="18288">
+            <a:normAutofit/>
           </a:bodyPr>
           <a:lstStyle/>
           <a:p>
             <a:pPr algn="l">
+              <a:lnSpc>
+                <a:spcPts val="2000"/>
+              </a:lnSpc>
               <a:spcBef>
                 <a:spcPts val="0"/>
               </a:spcBef>
@@ -6114,12 +6225,15 @@
           <a:noFill/>
         </p:spPr>
         <p:txBody>
-          <a:bodyPr wrap="square">
-            <a:spAutoFit/>
+          <a:bodyPr wrap="square" lIns="36576" rIns="36576" tIns="18288" bIns="18288">
+            <a:normAutofit/>
           </a:bodyPr>
           <a:lstStyle/>
           <a:p>
             <a:pPr algn="l">
+              <a:lnSpc>
+                <a:spcPts val="3000"/>
+              </a:lnSpc>
               <a:spcBef>
                 <a:spcPts val="0"/>
               </a:spcBef>
@@ -6156,12 +6270,15 @@
           <a:noFill/>
         </p:spPr>
         <p:txBody>
-          <a:bodyPr wrap="square">
-            <a:spAutoFit/>
+          <a:bodyPr wrap="square" lIns="36576" rIns="36576" tIns="18288" bIns="18288">
+            <a:normAutofit/>
           </a:bodyPr>
           <a:lstStyle/>
           <a:p>
             <a:pPr algn="l">
+              <a:lnSpc>
+                <a:spcPts val="1700"/>
+              </a:lnSpc>
               <a:spcBef>
                 <a:spcPts val="0"/>
               </a:spcBef>
@@ -6241,12 +6358,15 @@
           <a:noFill/>
         </p:spPr>
         <p:txBody>
-          <a:bodyPr wrap="square">
-            <a:spAutoFit/>
+          <a:bodyPr wrap="square" lIns="36576" rIns="36576" tIns="18288" bIns="18288">
+            <a:normAutofit/>
           </a:bodyPr>
           <a:lstStyle/>
           <a:p>
             <a:pPr algn="ctr">
+              <a:lnSpc>
+                <a:spcPts val="1300"/>
+              </a:lnSpc>
               <a:spcBef>
                 <a:spcPts val="0"/>
               </a:spcBef>
@@ -6283,12 +6403,15 @@
           <a:noFill/>
         </p:spPr>
         <p:txBody>
-          <a:bodyPr wrap="square">
-            <a:spAutoFit/>
+          <a:bodyPr wrap="square" lIns="36576" rIns="36576" tIns="18288" bIns="18288">
+            <a:normAutofit/>
           </a:bodyPr>
           <a:lstStyle/>
           <a:p>
             <a:pPr algn="l">
+              <a:lnSpc>
+                <a:spcPts val="1700"/>
+              </a:lnSpc>
               <a:spcBef>
                 <a:spcPts val="0"/>
               </a:spcBef>
@@ -6368,12 +6491,15 @@
           <a:noFill/>
         </p:spPr>
         <p:txBody>
-          <a:bodyPr wrap="square">
-            <a:spAutoFit/>
+          <a:bodyPr wrap="square" lIns="36576" rIns="36576" tIns="18288" bIns="18288">
+            <a:normAutofit/>
           </a:bodyPr>
           <a:lstStyle/>
           <a:p>
             <a:pPr algn="ctr">
+              <a:lnSpc>
+                <a:spcPts val="1300"/>
+              </a:lnSpc>
               <a:spcBef>
                 <a:spcPts val="0"/>
               </a:spcBef>
@@ -6410,12 +6536,15 @@
           <a:noFill/>
         </p:spPr>
         <p:txBody>
-          <a:bodyPr wrap="square">
-            <a:spAutoFit/>
+          <a:bodyPr wrap="square" lIns="36576" rIns="36576" tIns="18288" bIns="18288">
+            <a:normAutofit/>
           </a:bodyPr>
           <a:lstStyle/>
           <a:p>
             <a:pPr algn="l">
+              <a:lnSpc>
+                <a:spcPts val="1700"/>
+              </a:lnSpc>
               <a:spcBef>
                 <a:spcPts val="0"/>
               </a:spcBef>
@@ -6495,12 +6624,15 @@
           <a:noFill/>
         </p:spPr>
         <p:txBody>
-          <a:bodyPr wrap="square">
-            <a:spAutoFit/>
+          <a:bodyPr wrap="square" lIns="36576" rIns="36576" tIns="18288" bIns="18288">
+            <a:normAutofit/>
           </a:bodyPr>
           <a:lstStyle/>
           <a:p>
             <a:pPr algn="ctr">
+              <a:lnSpc>
+                <a:spcPts val="1300"/>
+              </a:lnSpc>
               <a:spcBef>
                 <a:spcPts val="0"/>
               </a:spcBef>
@@ -6537,12 +6669,15 @@
           <a:noFill/>
         </p:spPr>
         <p:txBody>
-          <a:bodyPr wrap="square">
-            <a:spAutoFit/>
+          <a:bodyPr wrap="square" lIns="36576" rIns="36576" tIns="18288" bIns="18288">
+            <a:normAutofit/>
           </a:bodyPr>
           <a:lstStyle/>
           <a:p>
             <a:pPr algn="l">
+              <a:lnSpc>
+                <a:spcPts val="1700"/>
+              </a:lnSpc>
               <a:spcBef>
                 <a:spcPts val="0"/>
               </a:spcBef>
@@ -6622,12 +6757,15 @@
           <a:noFill/>
         </p:spPr>
         <p:txBody>
-          <a:bodyPr wrap="square">
-            <a:spAutoFit/>
+          <a:bodyPr wrap="square" lIns="36576" rIns="36576" tIns="18288" bIns="18288">
+            <a:normAutofit/>
           </a:bodyPr>
           <a:lstStyle/>
           <a:p>
             <a:pPr algn="ctr">
+              <a:lnSpc>
+                <a:spcPts val="1300"/>
+              </a:lnSpc>
               <a:spcBef>
                 <a:spcPts val="0"/>
               </a:spcBef>
@@ -6664,12 +6802,15 @@
           <a:noFill/>
         </p:spPr>
         <p:txBody>
-          <a:bodyPr wrap="square">
-            <a:spAutoFit/>
+          <a:bodyPr wrap="square" lIns="36576" rIns="36576" tIns="18288" bIns="18288">
+            <a:normAutofit/>
           </a:bodyPr>
           <a:lstStyle/>
           <a:p>
             <a:pPr algn="l">
+              <a:lnSpc>
+                <a:spcPts val="1700"/>
+              </a:lnSpc>
               <a:spcBef>
                 <a:spcPts val="0"/>
               </a:spcBef>
@@ -6792,12 +6933,15 @@
           <a:noFill/>
         </p:spPr>
         <p:txBody>
-          <a:bodyPr wrap="square">
-            <a:spAutoFit/>
+          <a:bodyPr wrap="square" lIns="36576" rIns="36576" tIns="18288" bIns="18288">
+            <a:normAutofit/>
           </a:bodyPr>
           <a:lstStyle/>
           <a:p>
             <a:pPr algn="l">
+              <a:lnSpc>
+                <a:spcPts val="3000"/>
+              </a:lnSpc>
               <a:spcBef>
                 <a:spcPts val="0"/>
               </a:spcBef>
@@ -6834,12 +6978,15 @@
           <a:noFill/>
         </p:spPr>
         <p:txBody>
-          <a:bodyPr wrap="square">
-            <a:spAutoFit/>
+          <a:bodyPr wrap="square" lIns="36576" rIns="36576" tIns="18288" bIns="18288">
+            <a:normAutofit/>
           </a:bodyPr>
           <a:lstStyle/>
           <a:p>
             <a:pPr algn="l">
+              <a:lnSpc>
+                <a:spcPts val="1700"/>
+              </a:lnSpc>
               <a:spcBef>
                 <a:spcPts val="0"/>
               </a:spcBef>
@@ -6919,12 +7066,15 @@
           <a:noFill/>
         </p:spPr>
         <p:txBody>
-          <a:bodyPr wrap="square">
-            <a:spAutoFit/>
+          <a:bodyPr wrap="square" lIns="36576" rIns="36576" tIns="18288" bIns="18288">
+            <a:normAutofit/>
           </a:bodyPr>
           <a:lstStyle/>
           <a:p>
             <a:pPr algn="ctr">
+              <a:lnSpc>
+                <a:spcPts val="1300"/>
+              </a:lnSpc>
               <a:spcBef>
                 <a:spcPts val="0"/>
               </a:spcBef>
@@ -6961,12 +7111,15 @@
           <a:noFill/>
         </p:spPr>
         <p:txBody>
-          <a:bodyPr wrap="square">
-            <a:spAutoFit/>
+          <a:bodyPr wrap="square" lIns="36576" rIns="36576" tIns="18288" bIns="18288">
+            <a:normAutofit/>
           </a:bodyPr>
           <a:lstStyle/>
           <a:p>
             <a:pPr algn="l">
+              <a:lnSpc>
+                <a:spcPts val="1700"/>
+              </a:lnSpc>
               <a:spcBef>
                 <a:spcPts val="0"/>
               </a:spcBef>
@@ -7046,12 +7199,15 @@
           <a:noFill/>
         </p:spPr>
         <p:txBody>
-          <a:bodyPr wrap="square">
-            <a:spAutoFit/>
+          <a:bodyPr wrap="square" lIns="36576" rIns="36576" tIns="18288" bIns="18288">
+            <a:normAutofit/>
           </a:bodyPr>
           <a:lstStyle/>
           <a:p>
             <a:pPr algn="ctr">
+              <a:lnSpc>
+                <a:spcPts val="1300"/>
+              </a:lnSpc>
               <a:spcBef>
                 <a:spcPts val="0"/>
               </a:spcBef>
@@ -7088,12 +7244,15 @@
           <a:noFill/>
         </p:spPr>
         <p:txBody>
-          <a:bodyPr wrap="square">
-            <a:spAutoFit/>
+          <a:bodyPr wrap="square" lIns="36576" rIns="36576" tIns="18288" bIns="18288">
+            <a:normAutofit/>
           </a:bodyPr>
           <a:lstStyle/>
           <a:p>
             <a:pPr algn="l">
+              <a:lnSpc>
+                <a:spcPts val="1700"/>
+              </a:lnSpc>
               <a:spcBef>
                 <a:spcPts val="0"/>
               </a:spcBef>
@@ -7173,12 +7332,15 @@
           <a:noFill/>
         </p:spPr>
         <p:txBody>
-          <a:bodyPr wrap="square">
-            <a:spAutoFit/>
+          <a:bodyPr wrap="square" lIns="36576" rIns="36576" tIns="18288" bIns="18288">
+            <a:normAutofit/>
           </a:bodyPr>
           <a:lstStyle/>
           <a:p>
             <a:pPr algn="ctr">
+              <a:lnSpc>
+                <a:spcPts val="1300"/>
+              </a:lnSpc>
               <a:spcBef>
                 <a:spcPts val="0"/>
               </a:spcBef>
@@ -7215,12 +7377,15 @@
           <a:noFill/>
         </p:spPr>
         <p:txBody>
-          <a:bodyPr wrap="square">
-            <a:spAutoFit/>
+          <a:bodyPr wrap="square" lIns="36576" rIns="36576" tIns="18288" bIns="18288">
+            <a:normAutofit/>
           </a:bodyPr>
           <a:lstStyle/>
           <a:p>
             <a:pPr algn="l">
+              <a:lnSpc>
+                <a:spcPts val="1700"/>
+              </a:lnSpc>
               <a:spcBef>
                 <a:spcPts val="0"/>
               </a:spcBef>
@@ -7300,12 +7465,15 @@
           <a:noFill/>
         </p:spPr>
         <p:txBody>
-          <a:bodyPr wrap="square">
-            <a:spAutoFit/>
+          <a:bodyPr wrap="square" lIns="36576" rIns="36576" tIns="18288" bIns="18288">
+            <a:normAutofit/>
           </a:bodyPr>
           <a:lstStyle/>
           <a:p>
             <a:pPr algn="ctr">
+              <a:lnSpc>
+                <a:spcPts val="1300"/>
+              </a:lnSpc>
               <a:spcBef>
                 <a:spcPts val="0"/>
               </a:spcBef>
@@ -7342,12 +7510,15 @@
           <a:noFill/>
         </p:spPr>
         <p:txBody>
-          <a:bodyPr wrap="square">
-            <a:spAutoFit/>
+          <a:bodyPr wrap="square" lIns="36576" rIns="36576" tIns="18288" bIns="18288">
+            <a:normAutofit/>
           </a:bodyPr>
           <a:lstStyle/>
           <a:p>
             <a:pPr algn="l">
+              <a:lnSpc>
+                <a:spcPts val="1700"/>
+              </a:lnSpc>
               <a:spcBef>
                 <a:spcPts val="0"/>
               </a:spcBef>
@@ -7453,12 +7624,15 @@
           <a:noFill/>
         </p:spPr>
         <p:txBody>
-          <a:bodyPr wrap="square">
-            <a:spAutoFit/>
+          <a:bodyPr wrap="square" lIns="36576" rIns="36576" tIns="18288" bIns="18288">
+            <a:normAutofit/>
           </a:bodyPr>
           <a:lstStyle/>
           <a:p>
             <a:pPr algn="l">
+              <a:lnSpc>
+                <a:spcPts val="1600"/>
+              </a:lnSpc>
               <a:spcBef>
                 <a:spcPts val="0"/>
               </a:spcBef>
@@ -7495,12 +7669,15 @@
           <a:noFill/>
         </p:spPr>
         <p:txBody>
-          <a:bodyPr wrap="square">
-            <a:spAutoFit/>
+          <a:bodyPr wrap="square" lIns="36576" rIns="36576" tIns="18288" bIns="18288">
+            <a:normAutofit/>
           </a:bodyPr>
           <a:lstStyle/>
           <a:p>
             <a:pPr algn="l">
+              <a:lnSpc>
+                <a:spcPts val="4700"/>
+              </a:lnSpc>
               <a:spcBef>
                 <a:spcPts val="0"/>
               </a:spcBef>
@@ -7666,12 +7843,15 @@
           <a:noFill/>
         </p:spPr>
         <p:txBody>
-          <a:bodyPr wrap="square">
-            <a:spAutoFit/>
+          <a:bodyPr wrap="square" lIns="36576" rIns="36576" tIns="18288" bIns="18288">
+            <a:normAutofit/>
           </a:bodyPr>
           <a:lstStyle/>
           <a:p>
             <a:pPr algn="ctr">
+              <a:lnSpc>
+                <a:spcPts val="3000"/>
+              </a:lnSpc>
               <a:spcBef>
                 <a:spcPts val="0"/>
               </a:spcBef>
@@ -7708,12 +7888,15 @@
           <a:noFill/>
         </p:spPr>
         <p:txBody>
-          <a:bodyPr wrap="square">
-            <a:spAutoFit/>
+          <a:bodyPr wrap="square" lIns="36576" rIns="36576" tIns="18288" bIns="18288">
+            <a:normAutofit/>
           </a:bodyPr>
           <a:lstStyle/>
           <a:p>
             <a:pPr algn="ctr">
+              <a:lnSpc>
+                <a:spcPts val="2200"/>
+              </a:lnSpc>
               <a:spcBef>
                 <a:spcPts val="0"/>
               </a:spcBef>
@@ -7750,12 +7933,15 @@
           <a:noFill/>
         </p:spPr>
         <p:txBody>
-          <a:bodyPr wrap="square">
-            <a:spAutoFit/>
+          <a:bodyPr wrap="square" lIns="36576" rIns="36576" tIns="18288" bIns="18288">
+            <a:normAutofit/>
           </a:bodyPr>
           <a:lstStyle/>
           <a:p>
             <a:pPr algn="ctr">
+              <a:lnSpc>
+                <a:spcPts val="1600"/>
+              </a:lnSpc>
               <a:spcBef>
                 <a:spcPts val="0"/>
               </a:spcBef>
@@ -7921,12 +8107,15 @@
           <a:noFill/>
         </p:spPr>
         <p:txBody>
-          <a:bodyPr wrap="square">
-            <a:spAutoFit/>
+          <a:bodyPr wrap="square" lIns="36576" rIns="36576" tIns="18288" bIns="18288">
+            <a:normAutofit/>
           </a:bodyPr>
           <a:lstStyle/>
           <a:p>
             <a:pPr algn="ctr">
+              <a:lnSpc>
+                <a:spcPts val="3000"/>
+              </a:lnSpc>
               <a:spcBef>
                 <a:spcPts val="0"/>
               </a:spcBef>
@@ -7963,12 +8152,15 @@
           <a:noFill/>
         </p:spPr>
         <p:txBody>
-          <a:bodyPr wrap="square">
-            <a:spAutoFit/>
+          <a:bodyPr wrap="square" lIns="36576" rIns="36576" tIns="18288" bIns="18288">
+            <a:normAutofit/>
           </a:bodyPr>
           <a:lstStyle/>
           <a:p>
             <a:pPr algn="ctr">
+              <a:lnSpc>
+                <a:spcPts val="2200"/>
+              </a:lnSpc>
               <a:spcBef>
                 <a:spcPts val="0"/>
               </a:spcBef>
@@ -8005,12 +8197,15 @@
           <a:noFill/>
         </p:spPr>
         <p:txBody>
-          <a:bodyPr wrap="square">
-            <a:spAutoFit/>
+          <a:bodyPr wrap="square" lIns="36576" rIns="36576" tIns="18288" bIns="18288">
+            <a:normAutofit/>
           </a:bodyPr>
           <a:lstStyle/>
           <a:p>
             <a:pPr algn="ctr">
+              <a:lnSpc>
+                <a:spcPts val="1600"/>
+              </a:lnSpc>
               <a:spcBef>
                 <a:spcPts val="0"/>
               </a:spcBef>
@@ -8176,12 +8371,15 @@
           <a:noFill/>
         </p:spPr>
         <p:txBody>
-          <a:bodyPr wrap="square">
-            <a:spAutoFit/>
+          <a:bodyPr wrap="square" lIns="36576" rIns="36576" tIns="18288" bIns="18288">
+            <a:normAutofit/>
           </a:bodyPr>
           <a:lstStyle/>
           <a:p>
             <a:pPr algn="ctr">
+              <a:lnSpc>
+                <a:spcPts val="3000"/>
+              </a:lnSpc>
               <a:spcBef>
                 <a:spcPts val="0"/>
               </a:spcBef>
@@ -8218,12 +8416,15 @@
           <a:noFill/>
         </p:spPr>
         <p:txBody>
-          <a:bodyPr wrap="square">
-            <a:spAutoFit/>
+          <a:bodyPr wrap="square" lIns="36576" rIns="36576" tIns="18288" bIns="18288">
+            <a:normAutofit/>
           </a:bodyPr>
           <a:lstStyle/>
           <a:p>
             <a:pPr algn="ctr">
+              <a:lnSpc>
+                <a:spcPts val="2200"/>
+              </a:lnSpc>
               <a:spcBef>
                 <a:spcPts val="0"/>
               </a:spcBef>
@@ -8260,12 +8461,15 @@
           <a:noFill/>
         </p:spPr>
         <p:txBody>
-          <a:bodyPr wrap="square">
-            <a:spAutoFit/>
+          <a:bodyPr wrap="square" lIns="36576" rIns="36576" tIns="18288" bIns="18288">
+            <a:normAutofit/>
           </a:bodyPr>
           <a:lstStyle/>
           <a:p>
             <a:pPr algn="ctr">
+              <a:lnSpc>
+                <a:spcPts val="1600"/>
+              </a:lnSpc>
               <a:spcBef>
                 <a:spcPts val="0"/>
               </a:spcBef>
@@ -8371,12 +8575,15 @@
           <a:noFill/>
         </p:spPr>
         <p:txBody>
-          <a:bodyPr wrap="square">
-            <a:spAutoFit/>
+          <a:bodyPr wrap="square" lIns="36576" rIns="36576" tIns="18288" bIns="18288">
+            <a:normAutofit/>
           </a:bodyPr>
           <a:lstStyle/>
           <a:p>
             <a:pPr algn="l">
+              <a:lnSpc>
+                <a:spcPts val="1600"/>
+              </a:lnSpc>
               <a:spcBef>
                 <a:spcPts val="0"/>
               </a:spcBef>
@@ -8413,12 +8620,15 @@
           <a:noFill/>
         </p:spPr>
         <p:txBody>
-          <a:bodyPr wrap="square">
-            <a:spAutoFit/>
+          <a:bodyPr wrap="square" lIns="36576" rIns="36576" tIns="18288" bIns="18288">
+            <a:normAutofit/>
           </a:bodyPr>
           <a:lstStyle/>
           <a:p>
             <a:pPr algn="l">
+              <a:lnSpc>
+                <a:spcPts val="4700"/>
+              </a:lnSpc>
               <a:spcBef>
                 <a:spcPts val="0"/>
               </a:spcBef>
@@ -8584,12 +8794,15 @@
           <a:noFill/>
         </p:spPr>
         <p:txBody>
-          <a:bodyPr wrap="square">
-            <a:spAutoFit/>
+          <a:bodyPr wrap="square" lIns="36576" rIns="36576" tIns="18288" bIns="18288">
+            <a:normAutofit/>
           </a:bodyPr>
           <a:lstStyle/>
           <a:p>
             <a:pPr algn="ctr">
+              <a:lnSpc>
+                <a:spcPts val="3000"/>
+              </a:lnSpc>
               <a:spcBef>
                 <a:spcPts val="0"/>
               </a:spcBef>
@@ -8626,12 +8839,15 @@
           <a:noFill/>
         </p:spPr>
         <p:txBody>
-          <a:bodyPr wrap="square">
-            <a:spAutoFit/>
+          <a:bodyPr wrap="square" lIns="36576" rIns="36576" tIns="18288" bIns="18288">
+            <a:normAutofit/>
           </a:bodyPr>
           <a:lstStyle/>
           <a:p>
             <a:pPr algn="ctr">
+              <a:lnSpc>
+                <a:spcPts val="2200"/>
+              </a:lnSpc>
               <a:spcBef>
                 <a:spcPts val="0"/>
               </a:spcBef>
@@ -8668,12 +8884,15 @@
           <a:noFill/>
         </p:spPr>
         <p:txBody>
-          <a:bodyPr wrap="square">
-            <a:spAutoFit/>
+          <a:bodyPr wrap="square" lIns="36576" rIns="36576" tIns="18288" bIns="18288">
+            <a:normAutofit/>
           </a:bodyPr>
           <a:lstStyle/>
           <a:p>
             <a:pPr algn="ctr">
+              <a:lnSpc>
+                <a:spcPts val="1600"/>
+              </a:lnSpc>
               <a:spcBef>
                 <a:spcPts val="0"/>
               </a:spcBef>
@@ -8839,12 +9058,15 @@
           <a:noFill/>
         </p:spPr>
         <p:txBody>
-          <a:bodyPr wrap="square">
-            <a:spAutoFit/>
+          <a:bodyPr wrap="square" lIns="36576" rIns="36576" tIns="18288" bIns="18288">
+            <a:normAutofit/>
           </a:bodyPr>
           <a:lstStyle/>
           <a:p>
             <a:pPr algn="ctr">
+              <a:lnSpc>
+                <a:spcPts val="3000"/>
+              </a:lnSpc>
               <a:spcBef>
                 <a:spcPts val="0"/>
               </a:spcBef>
@@ -8881,12 +9103,15 @@
           <a:noFill/>
         </p:spPr>
         <p:txBody>
-          <a:bodyPr wrap="square">
-            <a:spAutoFit/>
+          <a:bodyPr wrap="square" lIns="36576" rIns="36576" tIns="18288" bIns="18288">
+            <a:normAutofit/>
           </a:bodyPr>
           <a:lstStyle/>
           <a:p>
             <a:pPr algn="ctr">
+              <a:lnSpc>
+                <a:spcPts val="2200"/>
+              </a:lnSpc>
               <a:spcBef>
                 <a:spcPts val="0"/>
               </a:spcBef>
@@ -8923,12 +9148,15 @@
           <a:noFill/>
         </p:spPr>
         <p:txBody>
-          <a:bodyPr wrap="square">
-            <a:spAutoFit/>
+          <a:bodyPr wrap="square" lIns="36576" rIns="36576" tIns="18288" bIns="18288">
+            <a:normAutofit/>
           </a:bodyPr>
           <a:lstStyle/>
           <a:p>
             <a:pPr algn="ctr">
+              <a:lnSpc>
+                <a:spcPts val="1600"/>
+              </a:lnSpc>
               <a:spcBef>
                 <a:spcPts val="0"/>
               </a:spcBef>
@@ -9094,12 +9322,15 @@
           <a:noFill/>
         </p:spPr>
         <p:txBody>
-          <a:bodyPr wrap="square">
-            <a:spAutoFit/>
+          <a:bodyPr wrap="square" lIns="36576" rIns="36576" tIns="18288" bIns="18288">
+            <a:normAutofit/>
           </a:bodyPr>
           <a:lstStyle/>
           <a:p>
             <a:pPr algn="ctr">
+              <a:lnSpc>
+                <a:spcPts val="3000"/>
+              </a:lnSpc>
               <a:spcBef>
                 <a:spcPts val="0"/>
               </a:spcBef>
@@ -9136,12 +9367,15 @@
           <a:noFill/>
         </p:spPr>
         <p:txBody>
-          <a:bodyPr wrap="square">
-            <a:spAutoFit/>
+          <a:bodyPr wrap="square" lIns="36576" rIns="36576" tIns="18288" bIns="18288">
+            <a:normAutofit/>
           </a:bodyPr>
           <a:lstStyle/>
           <a:p>
             <a:pPr algn="ctr">
+              <a:lnSpc>
+                <a:spcPts val="2200"/>
+              </a:lnSpc>
               <a:spcBef>
                 <a:spcPts val="0"/>
               </a:spcBef>
@@ -9178,12 +9412,15 @@
           <a:noFill/>
         </p:spPr>
         <p:txBody>
-          <a:bodyPr wrap="square">
-            <a:spAutoFit/>
+          <a:bodyPr wrap="square" lIns="36576" rIns="36576" tIns="18288" bIns="18288">
+            <a:normAutofit/>
           </a:bodyPr>
           <a:lstStyle/>
           <a:p>
             <a:pPr algn="ctr">
+              <a:lnSpc>
+                <a:spcPts val="1600"/>
+              </a:lnSpc>
               <a:spcBef>
                 <a:spcPts val="0"/>
               </a:spcBef>
@@ -9289,12 +9526,15 @@
           <a:noFill/>
         </p:spPr>
         <p:txBody>
-          <a:bodyPr wrap="square">
-            <a:spAutoFit/>
+          <a:bodyPr wrap="square" lIns="36576" rIns="36576" tIns="18288" bIns="18288">
+            <a:normAutofit/>
           </a:bodyPr>
           <a:lstStyle/>
           <a:p>
             <a:pPr algn="l">
+              <a:lnSpc>
+                <a:spcPts val="1600"/>
+              </a:lnSpc>
               <a:spcBef>
                 <a:spcPts val="0"/>
               </a:spcBef>
@@ -9331,12 +9571,15 @@
           <a:noFill/>
         </p:spPr>
         <p:txBody>
-          <a:bodyPr wrap="square">
-            <a:spAutoFit/>
+          <a:bodyPr wrap="square" lIns="36576" rIns="36576" tIns="18288" bIns="18288">
+            <a:normAutofit/>
           </a:bodyPr>
           <a:lstStyle/>
           <a:p>
             <a:pPr algn="l">
+              <a:lnSpc>
+                <a:spcPts val="4500"/>
+              </a:lnSpc>
               <a:spcBef>
                 <a:spcPts val="0"/>
               </a:spcBef>
@@ -9459,12 +9702,15 @@
           <a:noFill/>
         </p:spPr>
         <p:txBody>
-          <a:bodyPr wrap="square">
-            <a:spAutoFit/>
+          <a:bodyPr wrap="square" lIns="36576" rIns="36576" tIns="18288" bIns="18288">
+            <a:normAutofit/>
           </a:bodyPr>
           <a:lstStyle/>
           <a:p>
             <a:pPr algn="l">
+              <a:lnSpc>
+                <a:spcPts val="2500"/>
+              </a:lnSpc>
               <a:spcBef>
                 <a:spcPts val="0"/>
               </a:spcBef>
@@ -9501,14 +9747,20 @@
           <a:noFill/>
         </p:spPr>
         <p:txBody>
-          <a:bodyPr wrap="square">
-            <a:spAutoFit/>
+          <a:bodyPr wrap="square" lIns="36576" rIns="36576" tIns="18288" bIns="18288">
+            <a:normAutofit/>
           </a:bodyPr>
           <a:lstStyle/>
           <a:p>
             <a:pPr algn="l">
-              <a:spcAft>
-                <a:spcPts val="520"/>
+              <a:lnSpc>
+                <a:spcPts val="1600"/>
+              </a:lnSpc>
+              <a:spcBef>
+                <a:spcPts val="0"/>
+              </a:spcBef>
+              <a:spcAft>
+                <a:spcPts val="400"/>
               </a:spcAft>
               <a:defRPr sz="1300" b="0">
                 <a:solidFill>
@@ -9523,8 +9775,14 @@
           </a:p>
           <a:p>
             <a:pPr algn="l">
-              <a:spcAft>
-                <a:spcPts val="520"/>
+              <a:lnSpc>
+                <a:spcPts val="1600"/>
+              </a:lnSpc>
+              <a:spcBef>
+                <a:spcPts val="0"/>
+              </a:spcBef>
+              <a:spcAft>
+                <a:spcPts val="400"/>
               </a:spcAft>
               <a:defRPr sz="1300" b="0">
                 <a:solidFill>
@@ -9539,8 +9797,14 @@
           </a:p>
           <a:p>
             <a:pPr algn="l">
-              <a:spcAft>
-                <a:spcPts val="520"/>
+              <a:lnSpc>
+                <a:spcPts val="1600"/>
+              </a:lnSpc>
+              <a:spcBef>
+                <a:spcPts val="0"/>
+              </a:spcBef>
+              <a:spcAft>
+                <a:spcPts val="400"/>
               </a:spcAft>
               <a:defRPr sz="1300" b="0">
                 <a:solidFill>
@@ -9555,8 +9819,14 @@
           </a:p>
           <a:p>
             <a:pPr algn="l">
-              <a:spcAft>
-                <a:spcPts val="520"/>
+              <a:lnSpc>
+                <a:spcPts val="1600"/>
+              </a:lnSpc>
+              <a:spcBef>
+                <a:spcPts val="0"/>
+              </a:spcBef>
+              <a:spcAft>
+                <a:spcPts val="400"/>
               </a:spcAft>
               <a:defRPr sz="1300" b="0">
                 <a:solidFill>
@@ -9674,12 +9944,15 @@
           <a:noFill/>
         </p:spPr>
         <p:txBody>
-          <a:bodyPr wrap="square">
-            <a:spAutoFit/>
+          <a:bodyPr wrap="square" lIns="36576" rIns="36576" tIns="18288" bIns="18288">
+            <a:normAutofit/>
           </a:bodyPr>
           <a:lstStyle/>
           <a:p>
             <a:pPr algn="l">
+              <a:lnSpc>
+                <a:spcPts val="2500"/>
+              </a:lnSpc>
               <a:spcBef>
                 <a:spcPts val="0"/>
               </a:spcBef>
@@ -9716,14 +9989,20 @@
           <a:noFill/>
         </p:spPr>
         <p:txBody>
-          <a:bodyPr wrap="square">
-            <a:spAutoFit/>
+          <a:bodyPr wrap="square" lIns="36576" rIns="36576" tIns="18288" bIns="18288">
+            <a:normAutofit/>
           </a:bodyPr>
           <a:lstStyle/>
           <a:p>
             <a:pPr algn="l">
-              <a:spcAft>
-                <a:spcPts val="520"/>
+              <a:lnSpc>
+                <a:spcPts val="1600"/>
+              </a:lnSpc>
+              <a:spcBef>
+                <a:spcPts val="0"/>
+              </a:spcBef>
+              <a:spcAft>
+                <a:spcPts val="400"/>
               </a:spcAft>
               <a:defRPr sz="1300" b="0">
                 <a:solidFill>
@@ -9738,8 +10017,14 @@
           </a:p>
           <a:p>
             <a:pPr algn="l">
-              <a:spcAft>
-                <a:spcPts val="520"/>
+              <a:lnSpc>
+                <a:spcPts val="1600"/>
+              </a:lnSpc>
+              <a:spcBef>
+                <a:spcPts val="0"/>
+              </a:spcBef>
+              <a:spcAft>
+                <a:spcPts val="400"/>
               </a:spcAft>
               <a:defRPr sz="1300" b="0">
                 <a:solidFill>
@@ -9754,8 +10039,14 @@
           </a:p>
           <a:p>
             <a:pPr algn="l">
-              <a:spcAft>
-                <a:spcPts val="520"/>
+              <a:lnSpc>
+                <a:spcPts val="1600"/>
+              </a:lnSpc>
+              <a:spcBef>
+                <a:spcPts val="0"/>
+              </a:spcBef>
+              <a:spcAft>
+                <a:spcPts val="400"/>
               </a:spcAft>
               <a:defRPr sz="1300" b="0">
                 <a:solidFill>
@@ -9770,8 +10061,14 @@
           </a:p>
           <a:p>
             <a:pPr algn="l">
-              <a:spcAft>
-                <a:spcPts val="520"/>
+              <a:lnSpc>
+                <a:spcPts val="1600"/>
+              </a:lnSpc>
+              <a:spcBef>
+                <a:spcPts val="0"/>
+              </a:spcBef>
+              <a:spcAft>
+                <a:spcPts val="400"/>
               </a:spcAft>
               <a:defRPr sz="1300" b="0">
                 <a:solidFill>
@@ -9889,12 +10186,15 @@
           <a:noFill/>
         </p:spPr>
         <p:txBody>
-          <a:bodyPr wrap="square">
-            <a:spAutoFit/>
+          <a:bodyPr wrap="square" lIns="36576" rIns="36576" tIns="18288" bIns="18288">
+            <a:normAutofit/>
           </a:bodyPr>
           <a:lstStyle/>
           <a:p>
             <a:pPr algn="l">
+              <a:lnSpc>
+                <a:spcPts val="2500"/>
+              </a:lnSpc>
               <a:spcBef>
                 <a:spcPts val="0"/>
               </a:spcBef>
@@ -9931,14 +10231,20 @@
           <a:noFill/>
         </p:spPr>
         <p:txBody>
-          <a:bodyPr wrap="square">
-            <a:spAutoFit/>
+          <a:bodyPr wrap="square" lIns="36576" rIns="36576" tIns="18288" bIns="18288">
+            <a:normAutofit/>
           </a:bodyPr>
           <a:lstStyle/>
           <a:p>
             <a:pPr algn="l">
-              <a:spcAft>
-                <a:spcPts val="520"/>
+              <a:lnSpc>
+                <a:spcPts val="1600"/>
+              </a:lnSpc>
+              <a:spcBef>
+                <a:spcPts val="0"/>
+              </a:spcBef>
+              <a:spcAft>
+                <a:spcPts val="400"/>
               </a:spcAft>
               <a:defRPr sz="1300" b="0">
                 <a:solidFill>
@@ -9953,8 +10259,14 @@
           </a:p>
           <a:p>
             <a:pPr algn="l">
-              <a:spcAft>
-                <a:spcPts val="520"/>
+              <a:lnSpc>
+                <a:spcPts val="1600"/>
+              </a:lnSpc>
+              <a:spcBef>
+                <a:spcPts val="0"/>
+              </a:spcBef>
+              <a:spcAft>
+                <a:spcPts val="400"/>
               </a:spcAft>
               <a:defRPr sz="1300" b="0">
                 <a:solidFill>
@@ -9969,8 +10281,14 @@
           </a:p>
           <a:p>
             <a:pPr algn="l">
-              <a:spcAft>
-                <a:spcPts val="520"/>
+              <a:lnSpc>
+                <a:spcPts val="1600"/>
+              </a:lnSpc>
+              <a:spcBef>
+                <a:spcPts val="0"/>
+              </a:spcBef>
+              <a:spcAft>
+                <a:spcPts val="400"/>
               </a:spcAft>
               <a:defRPr sz="1300" b="0">
                 <a:solidFill>
@@ -9985,8 +10303,14 @@
           </a:p>
           <a:p>
             <a:pPr algn="l">
-              <a:spcAft>
-                <a:spcPts val="520"/>
+              <a:lnSpc>
+                <a:spcPts val="1600"/>
+              </a:lnSpc>
+              <a:spcBef>
+                <a:spcPts val="0"/>
+              </a:spcBef>
+              <a:spcAft>
+                <a:spcPts val="400"/>
               </a:spcAft>
               <a:defRPr sz="1300" b="0">
                 <a:solidFill>
@@ -10104,12 +10428,15 @@
           <a:noFill/>
         </p:spPr>
         <p:txBody>
-          <a:bodyPr wrap="square">
-            <a:spAutoFit/>
+          <a:bodyPr wrap="square" lIns="36576" rIns="36576" tIns="18288" bIns="18288">
+            <a:normAutofit/>
           </a:bodyPr>
           <a:lstStyle/>
           <a:p>
             <a:pPr algn="l">
+              <a:lnSpc>
+                <a:spcPts val="2500"/>
+              </a:lnSpc>
               <a:spcBef>
                 <a:spcPts val="0"/>
               </a:spcBef>
@@ -10146,14 +10473,20 @@
           <a:noFill/>
         </p:spPr>
         <p:txBody>
-          <a:bodyPr wrap="square">
-            <a:spAutoFit/>
+          <a:bodyPr wrap="square" lIns="36576" rIns="36576" tIns="18288" bIns="18288">
+            <a:normAutofit/>
           </a:bodyPr>
           <a:lstStyle/>
           <a:p>
             <a:pPr algn="l">
-              <a:spcAft>
-                <a:spcPts val="520"/>
+              <a:lnSpc>
+                <a:spcPts val="1600"/>
+              </a:lnSpc>
+              <a:spcBef>
+                <a:spcPts val="0"/>
+              </a:spcBef>
+              <a:spcAft>
+                <a:spcPts val="400"/>
               </a:spcAft>
               <a:defRPr sz="1300" b="0">
                 <a:solidFill>
@@ -10168,8 +10501,14 @@
           </a:p>
           <a:p>
             <a:pPr algn="l">
-              <a:spcAft>
-                <a:spcPts val="520"/>
+              <a:lnSpc>
+                <a:spcPts val="1600"/>
+              </a:lnSpc>
+              <a:spcBef>
+                <a:spcPts val="0"/>
+              </a:spcBef>
+              <a:spcAft>
+                <a:spcPts val="400"/>
               </a:spcAft>
               <a:defRPr sz="1300" b="0">
                 <a:solidFill>
@@ -10184,8 +10523,14 @@
           </a:p>
           <a:p>
             <a:pPr algn="l">
-              <a:spcAft>
-                <a:spcPts val="520"/>
+              <a:lnSpc>
+                <a:spcPts val="1600"/>
+              </a:lnSpc>
+              <a:spcBef>
+                <a:spcPts val="0"/>
+              </a:spcBef>
+              <a:spcAft>
+                <a:spcPts val="400"/>
               </a:spcAft>
               <a:defRPr sz="1300" b="0">
                 <a:solidFill>
@@ -10200,8 +10545,14 @@
           </a:p>
           <a:p>
             <a:pPr algn="l">
-              <a:spcAft>
-                <a:spcPts val="520"/>
+              <a:lnSpc>
+                <a:spcPts val="1600"/>
+              </a:lnSpc>
+              <a:spcBef>
+                <a:spcPts val="0"/>
+              </a:spcBef>
+              <a:spcAft>
+                <a:spcPts val="400"/>
               </a:spcAft>
               <a:defRPr sz="1300" b="0">
                 <a:solidFill>
@@ -10233,12 +10584,15 @@
           <a:noFill/>
         </p:spPr>
         <p:txBody>
-          <a:bodyPr wrap="square">
-            <a:spAutoFit/>
+          <a:bodyPr wrap="square" lIns="36576" rIns="36576" tIns="18288" bIns="18288">
+            <a:normAutofit/>
           </a:bodyPr>
           <a:lstStyle/>
           <a:p>
             <a:pPr algn="ctr">
+              <a:lnSpc>
+                <a:spcPts val="1600"/>
+              </a:lnSpc>
               <a:spcBef>
                 <a:spcPts val="0"/>
               </a:spcBef>
@@ -10344,12 +10698,15 @@
           <a:noFill/>
         </p:spPr>
         <p:txBody>
-          <a:bodyPr wrap="square">
-            <a:spAutoFit/>
+          <a:bodyPr wrap="square" lIns="36576" rIns="36576" tIns="18288" bIns="18288">
+            <a:normAutofit/>
           </a:bodyPr>
           <a:lstStyle/>
           <a:p>
             <a:pPr algn="l">
+              <a:lnSpc>
+                <a:spcPts val="1600"/>
+              </a:lnSpc>
               <a:spcBef>
                 <a:spcPts val="0"/>
               </a:spcBef>
@@ -10386,12 +10743,15 @@
           <a:noFill/>
         </p:spPr>
         <p:txBody>
-          <a:bodyPr wrap="square">
-            <a:spAutoFit/>
+          <a:bodyPr wrap="square" lIns="36576" rIns="36576" tIns="18288" bIns="18288">
+            <a:normAutofit/>
           </a:bodyPr>
           <a:lstStyle/>
           <a:p>
             <a:pPr algn="l">
+              <a:lnSpc>
+                <a:spcPts val="4700"/>
+              </a:lnSpc>
               <a:spcBef>
                 <a:spcPts val="0"/>
               </a:spcBef>
@@ -10471,12 +10831,15 @@
           <a:noFill/>
         </p:spPr>
         <p:txBody>
-          <a:bodyPr wrap="square">
-            <a:spAutoFit/>
+          <a:bodyPr wrap="square" lIns="36576" rIns="36576" tIns="18288" bIns="18288">
+            <a:normAutofit/>
           </a:bodyPr>
           <a:lstStyle/>
           <a:p>
             <a:pPr algn="ctr">
+              <a:lnSpc>
+                <a:spcPts val="6500"/>
+              </a:lnSpc>
               <a:spcBef>
                 <a:spcPts val="0"/>
               </a:spcBef>
@@ -10513,12 +10876,15 @@
           <a:noFill/>
         </p:spPr>
         <p:txBody>
-          <a:bodyPr wrap="square">
-            <a:spAutoFit/>
+          <a:bodyPr wrap="square" lIns="36576" rIns="36576" tIns="18288" bIns="18288">
+            <a:normAutofit/>
           </a:bodyPr>
           <a:lstStyle/>
           <a:p>
             <a:pPr algn="ctr">
+              <a:lnSpc>
+                <a:spcPts val="1800"/>
+              </a:lnSpc>
               <a:spcBef>
                 <a:spcPts val="0"/>
               </a:spcBef>
@@ -10598,12 +10964,15 @@
           <a:noFill/>
         </p:spPr>
         <p:txBody>
-          <a:bodyPr wrap="square">
-            <a:spAutoFit/>
+          <a:bodyPr wrap="square" lIns="36576" rIns="36576" tIns="18288" bIns="18288">
+            <a:normAutofit/>
           </a:bodyPr>
           <a:lstStyle/>
           <a:p>
             <a:pPr algn="ctr">
+              <a:lnSpc>
+                <a:spcPts val="6500"/>
+              </a:lnSpc>
               <a:spcBef>
                 <a:spcPts val="0"/>
               </a:spcBef>
@@ -10640,12 +11009,15 @@
           <a:noFill/>
         </p:spPr>
         <p:txBody>
-          <a:bodyPr wrap="square">
-            <a:spAutoFit/>
+          <a:bodyPr wrap="square" lIns="36576" rIns="36576" tIns="18288" bIns="18288">
+            <a:normAutofit/>
           </a:bodyPr>
           <a:lstStyle/>
           <a:p>
             <a:pPr algn="ctr">
+              <a:lnSpc>
+                <a:spcPts val="1800"/>
+              </a:lnSpc>
               <a:spcBef>
                 <a:spcPts val="0"/>
               </a:spcBef>
@@ -10725,12 +11097,15 @@
           <a:noFill/>
         </p:spPr>
         <p:txBody>
-          <a:bodyPr wrap="square">
-            <a:spAutoFit/>
+          <a:bodyPr wrap="square" lIns="36576" rIns="36576" tIns="18288" bIns="18288">
+            <a:normAutofit/>
           </a:bodyPr>
           <a:lstStyle/>
           <a:p>
             <a:pPr algn="ctr">
+              <a:lnSpc>
+                <a:spcPts val="6500"/>
+              </a:lnSpc>
               <a:spcBef>
                 <a:spcPts val="0"/>
               </a:spcBef>
@@ -10767,12 +11142,15 @@
           <a:noFill/>
         </p:spPr>
         <p:txBody>
-          <a:bodyPr wrap="square">
-            <a:spAutoFit/>
+          <a:bodyPr wrap="square" lIns="36576" rIns="36576" tIns="18288" bIns="18288">
+            <a:normAutofit/>
           </a:bodyPr>
           <a:lstStyle/>
           <a:p>
             <a:pPr algn="ctr">
+              <a:lnSpc>
+                <a:spcPts val="1800"/>
+              </a:lnSpc>
               <a:spcBef>
                 <a:spcPts val="0"/>
               </a:spcBef>
@@ -10852,12 +11230,15 @@
           <a:noFill/>
         </p:spPr>
         <p:txBody>
-          <a:bodyPr wrap="square">
-            <a:spAutoFit/>
+          <a:bodyPr wrap="square" lIns="36576" rIns="36576" tIns="18288" bIns="18288">
+            <a:normAutofit/>
           </a:bodyPr>
           <a:lstStyle/>
           <a:p>
             <a:pPr algn="ctr">
+              <a:lnSpc>
+                <a:spcPts val="6500"/>
+              </a:lnSpc>
               <a:spcBef>
                 <a:spcPts val="0"/>
               </a:spcBef>
@@ -10894,12 +11275,15 @@
           <a:noFill/>
         </p:spPr>
         <p:txBody>
-          <a:bodyPr wrap="square">
-            <a:spAutoFit/>
+          <a:bodyPr wrap="square" lIns="36576" rIns="36576" tIns="18288" bIns="18288">
+            <a:normAutofit/>
           </a:bodyPr>
           <a:lstStyle/>
           <a:p>
             <a:pPr algn="ctr">
+              <a:lnSpc>
+                <a:spcPts val="1800"/>
+              </a:lnSpc>
               <a:spcBef>
                 <a:spcPts val="0"/>
               </a:spcBef>
@@ -10979,12 +11363,15 @@
           <a:noFill/>
         </p:spPr>
         <p:txBody>
-          <a:bodyPr wrap="square">
-            <a:spAutoFit/>
+          <a:bodyPr wrap="square" lIns="36576" rIns="36576" tIns="18288" bIns="18288">
+            <a:normAutofit/>
           </a:bodyPr>
           <a:lstStyle/>
           <a:p>
             <a:pPr algn="ctr">
+              <a:lnSpc>
+                <a:spcPts val="6500"/>
+              </a:lnSpc>
               <a:spcBef>
                 <a:spcPts val="0"/>
               </a:spcBef>
@@ -11021,12 +11408,15 @@
           <a:noFill/>
         </p:spPr>
         <p:txBody>
-          <a:bodyPr wrap="square">
-            <a:spAutoFit/>
+          <a:bodyPr wrap="square" lIns="36576" rIns="36576" tIns="18288" bIns="18288">
+            <a:normAutofit/>
           </a:bodyPr>
           <a:lstStyle/>
           <a:p>
             <a:pPr algn="ctr">
+              <a:lnSpc>
+                <a:spcPts val="1800"/>
+              </a:lnSpc>
               <a:spcBef>
                 <a:spcPts val="0"/>
               </a:spcBef>
@@ -11106,12 +11496,15 @@
           <a:noFill/>
         </p:spPr>
         <p:txBody>
-          <a:bodyPr wrap="square">
-            <a:spAutoFit/>
+          <a:bodyPr wrap="square" lIns="36576" rIns="36576" tIns="18288" bIns="18288">
+            <a:normAutofit/>
           </a:bodyPr>
           <a:lstStyle/>
           <a:p>
             <a:pPr algn="ctr">
+              <a:lnSpc>
+                <a:spcPts val="6500"/>
+              </a:lnSpc>
               <a:spcBef>
                 <a:spcPts val="0"/>
               </a:spcBef>
@@ -11148,12 +11541,15 @@
           <a:noFill/>
         </p:spPr>
         <p:txBody>
-          <a:bodyPr wrap="square">
-            <a:spAutoFit/>
+          <a:bodyPr wrap="square" lIns="36576" rIns="36576" tIns="18288" bIns="18288">
+            <a:normAutofit/>
           </a:bodyPr>
           <a:lstStyle/>
           <a:p>
             <a:pPr algn="ctr">
+              <a:lnSpc>
+                <a:spcPts val="1800"/>
+              </a:lnSpc>
               <a:spcBef>
                 <a:spcPts val="0"/>
               </a:spcBef>
@@ -11259,12 +11655,15 @@
           <a:noFill/>
         </p:spPr>
         <p:txBody>
-          <a:bodyPr wrap="square">
-            <a:spAutoFit/>
+          <a:bodyPr wrap="square" lIns="36576" rIns="36576" tIns="18288" bIns="18288">
+            <a:normAutofit/>
           </a:bodyPr>
           <a:lstStyle/>
           <a:p>
             <a:pPr algn="l">
+              <a:lnSpc>
+                <a:spcPts val="1600"/>
+              </a:lnSpc>
               <a:spcBef>
                 <a:spcPts val="0"/>
               </a:spcBef>
@@ -11301,12 +11700,15 @@
           <a:noFill/>
         </p:spPr>
         <p:txBody>
-          <a:bodyPr wrap="square">
-            <a:spAutoFit/>
+          <a:bodyPr wrap="square" lIns="36576" rIns="36576" tIns="18288" bIns="18288">
+            <a:normAutofit/>
           </a:bodyPr>
           <a:lstStyle/>
           <a:p>
             <a:pPr algn="l">
+              <a:lnSpc>
+                <a:spcPts val="4700"/>
+              </a:lnSpc>
               <a:spcBef>
                 <a:spcPts val="0"/>
               </a:spcBef>
@@ -11386,12 +11788,15 @@
           <a:noFill/>
         </p:spPr>
         <p:txBody>
-          <a:bodyPr wrap="square">
-            <a:spAutoFit/>
+          <a:bodyPr wrap="square" lIns="36576" rIns="36576" tIns="18288" bIns="18288">
+            <a:normAutofit/>
           </a:bodyPr>
           <a:lstStyle/>
           <a:p>
             <a:pPr algn="l">
+              <a:lnSpc>
+                <a:spcPts val="2000"/>
+              </a:lnSpc>
               <a:spcBef>
                 <a:spcPts val="0"/>
               </a:spcBef>
@@ -11428,12 +11833,15 @@
           <a:noFill/>
         </p:spPr>
         <p:txBody>
-          <a:bodyPr wrap="square">
-            <a:spAutoFit/>
+          <a:bodyPr wrap="square" lIns="36576" rIns="36576" tIns="18288" bIns="18288">
+            <a:normAutofit/>
           </a:bodyPr>
           <a:lstStyle/>
           <a:p>
             <a:pPr algn="l">
+              <a:lnSpc>
+                <a:spcPts val="1700"/>
+              </a:lnSpc>
               <a:spcBef>
                 <a:spcPts val="0"/>
               </a:spcBef>
@@ -11513,12 +11921,15 @@
           <a:noFill/>
         </p:spPr>
         <p:txBody>
-          <a:bodyPr wrap="square">
-            <a:spAutoFit/>
+          <a:bodyPr wrap="square" lIns="36576" rIns="36576" tIns="18288" bIns="18288">
+            <a:normAutofit/>
           </a:bodyPr>
           <a:lstStyle/>
           <a:p>
             <a:pPr algn="l">
+              <a:lnSpc>
+                <a:spcPts val="2000"/>
+              </a:lnSpc>
               <a:spcBef>
                 <a:spcPts val="0"/>
               </a:spcBef>
@@ -11555,12 +11966,15 @@
           <a:noFill/>
         </p:spPr>
         <p:txBody>
-          <a:bodyPr wrap="square">
-            <a:spAutoFit/>
+          <a:bodyPr wrap="square" lIns="36576" rIns="36576" tIns="18288" bIns="18288">
+            <a:normAutofit/>
           </a:bodyPr>
           <a:lstStyle/>
           <a:p>
             <a:pPr algn="l">
+              <a:lnSpc>
+                <a:spcPts val="1700"/>
+              </a:lnSpc>
               <a:spcBef>
                 <a:spcPts val="0"/>
               </a:spcBef>
@@ -11640,12 +12054,15 @@
           <a:noFill/>
         </p:spPr>
         <p:txBody>
-          <a:bodyPr wrap="square">
-            <a:spAutoFit/>
+          <a:bodyPr wrap="square" lIns="36576" rIns="36576" tIns="18288" bIns="18288">
+            <a:normAutofit/>
           </a:bodyPr>
           <a:lstStyle/>
           <a:p>
             <a:pPr algn="l">
+              <a:lnSpc>
+                <a:spcPts val="2000"/>
+              </a:lnSpc>
               <a:spcBef>
                 <a:spcPts val="0"/>
               </a:spcBef>
@@ -11682,12 +12099,15 @@
           <a:noFill/>
         </p:spPr>
         <p:txBody>
-          <a:bodyPr wrap="square">
-            <a:spAutoFit/>
+          <a:bodyPr wrap="square" lIns="36576" rIns="36576" tIns="18288" bIns="18288">
+            <a:normAutofit/>
           </a:bodyPr>
           <a:lstStyle/>
           <a:p>
             <a:pPr algn="l">
+              <a:lnSpc>
+                <a:spcPts val="1700"/>
+              </a:lnSpc>
               <a:spcBef>
                 <a:spcPts val="0"/>
               </a:spcBef>
@@ -11767,12 +12187,15 @@
           <a:noFill/>
         </p:spPr>
         <p:txBody>
-          <a:bodyPr wrap="square">
-            <a:spAutoFit/>
+          <a:bodyPr wrap="square" lIns="36576" rIns="36576" tIns="18288" bIns="18288">
+            <a:normAutofit/>
           </a:bodyPr>
           <a:lstStyle/>
           <a:p>
             <a:pPr algn="l">
+              <a:lnSpc>
+                <a:spcPts val="2000"/>
+              </a:lnSpc>
               <a:spcBef>
                 <a:spcPts val="0"/>
               </a:spcBef>
@@ -11809,12 +12232,15 @@
           <a:noFill/>
         </p:spPr>
         <p:txBody>
-          <a:bodyPr wrap="square">
-            <a:spAutoFit/>
+          <a:bodyPr wrap="square" lIns="36576" rIns="36576" tIns="18288" bIns="18288">
+            <a:normAutofit/>
           </a:bodyPr>
           <a:lstStyle/>
           <a:p>
             <a:pPr algn="l">
+              <a:lnSpc>
+                <a:spcPts val="1700"/>
+              </a:lnSpc>
               <a:spcBef>
                 <a:spcPts val="0"/>
               </a:spcBef>
@@ -11894,12 +12320,15 @@
           <a:noFill/>
         </p:spPr>
         <p:txBody>
-          <a:bodyPr wrap="square">
-            <a:spAutoFit/>
+          <a:bodyPr wrap="square" lIns="36576" rIns="36576" tIns="18288" bIns="18288">
+            <a:normAutofit/>
           </a:bodyPr>
           <a:lstStyle/>
           <a:p>
             <a:pPr algn="l">
+              <a:lnSpc>
+                <a:spcPts val="2000"/>
+              </a:lnSpc>
               <a:spcBef>
                 <a:spcPts val="0"/>
               </a:spcBef>
@@ -11936,12 +12365,15 @@
           <a:noFill/>
         </p:spPr>
         <p:txBody>
-          <a:bodyPr wrap="square">
-            <a:spAutoFit/>
+          <a:bodyPr wrap="square" lIns="36576" rIns="36576" tIns="18288" bIns="18288">
+            <a:normAutofit/>
           </a:bodyPr>
           <a:lstStyle/>
           <a:p>
             <a:pPr algn="l">
+              <a:lnSpc>
+                <a:spcPts val="1700"/>
+              </a:lnSpc>
               <a:spcBef>
                 <a:spcPts val="0"/>
               </a:spcBef>
@@ -12047,12 +12479,15 @@
           <a:noFill/>
         </p:spPr>
         <p:txBody>
-          <a:bodyPr wrap="square">
-            <a:spAutoFit/>
+          <a:bodyPr wrap="square" lIns="36576" rIns="36576" tIns="18288" bIns="18288">
+            <a:normAutofit/>
           </a:bodyPr>
           <a:lstStyle/>
           <a:p>
             <a:pPr algn="l">
+              <a:lnSpc>
+                <a:spcPts val="1600"/>
+              </a:lnSpc>
               <a:spcBef>
                 <a:spcPts val="0"/>
               </a:spcBef>
@@ -12089,12 +12524,15 @@
           <a:noFill/>
         </p:spPr>
         <p:txBody>
-          <a:bodyPr wrap="square">
-            <a:spAutoFit/>
+          <a:bodyPr wrap="square" lIns="36576" rIns="36576" tIns="18288" bIns="18288">
+            <a:normAutofit/>
           </a:bodyPr>
           <a:lstStyle/>
           <a:p>
             <a:pPr algn="l">
+              <a:lnSpc>
+                <a:spcPts val="4500"/>
+              </a:lnSpc>
               <a:spcBef>
                 <a:spcPts val="0"/>
               </a:spcBef>
@@ -12217,12 +12655,15 @@
           <a:noFill/>
         </p:spPr>
         <p:txBody>
-          <a:bodyPr wrap="square">
-            <a:spAutoFit/>
+          <a:bodyPr wrap="square" lIns="36576" rIns="36576" tIns="18288" bIns="18288">
+            <a:normAutofit/>
           </a:bodyPr>
           <a:lstStyle/>
           <a:p>
             <a:pPr algn="ctr">
+              <a:lnSpc>
+                <a:spcPts val="3200"/>
+              </a:lnSpc>
               <a:spcBef>
                 <a:spcPts val="0"/>
               </a:spcBef>
@@ -12259,12 +12700,15 @@
           <a:noFill/>
         </p:spPr>
         <p:txBody>
-          <a:bodyPr wrap="square">
-            <a:spAutoFit/>
+          <a:bodyPr wrap="square" lIns="36576" rIns="36576" tIns="18288" bIns="18288">
+            <a:normAutofit/>
           </a:bodyPr>
           <a:lstStyle/>
           <a:p>
             <a:pPr algn="ctr">
+              <a:lnSpc>
+                <a:spcPts val="2100"/>
+              </a:lnSpc>
               <a:spcBef>
                 <a:spcPts val="0"/>
               </a:spcBef>
@@ -12301,14 +12745,20 @@
           <a:noFill/>
         </p:spPr>
         <p:txBody>
-          <a:bodyPr wrap="square">
-            <a:spAutoFit/>
+          <a:bodyPr wrap="square" lIns="36576" rIns="36576" tIns="18288" bIns="18288">
+            <a:normAutofit/>
           </a:bodyPr>
           <a:lstStyle/>
           <a:p>
             <a:pPr algn="ctr">
-              <a:spcAft>
-                <a:spcPts val="520"/>
+              <a:lnSpc>
+                <a:spcPts val="1600"/>
+              </a:lnSpc>
+              <a:spcBef>
+                <a:spcPts val="0"/>
+              </a:spcBef>
+              <a:spcAft>
+                <a:spcPts val="400"/>
               </a:spcAft>
               <a:defRPr sz="1300" b="0">
                 <a:solidFill>
@@ -12323,8 +12773,14 @@
           </a:p>
           <a:p>
             <a:pPr algn="ctr">
-              <a:spcAft>
-                <a:spcPts val="520"/>
+              <a:lnSpc>
+                <a:spcPts val="1600"/>
+              </a:lnSpc>
+              <a:spcBef>
+                <a:spcPts val="0"/>
+              </a:spcBef>
+              <a:spcAft>
+                <a:spcPts val="400"/>
               </a:spcAft>
               <a:defRPr sz="1300" b="0">
                 <a:solidFill>
@@ -12356,12 +12812,15 @@
           <a:noFill/>
         </p:spPr>
         <p:txBody>
-          <a:bodyPr wrap="square">
-            <a:spAutoFit/>
+          <a:bodyPr wrap="square" lIns="36576" rIns="36576" tIns="18288" bIns="18288">
+            <a:normAutofit/>
           </a:bodyPr>
           <a:lstStyle/>
           <a:p>
             <a:pPr algn="ctr">
+              <a:lnSpc>
+                <a:spcPts val="2200"/>
+              </a:lnSpc>
               <a:spcBef>
                 <a:spcPts val="0"/>
               </a:spcBef>
@@ -12484,12 +12943,15 @@
           <a:noFill/>
         </p:spPr>
         <p:txBody>
-          <a:bodyPr wrap="square">
-            <a:spAutoFit/>
+          <a:bodyPr wrap="square" lIns="36576" rIns="36576" tIns="18288" bIns="18288">
+            <a:normAutofit/>
           </a:bodyPr>
           <a:lstStyle/>
           <a:p>
             <a:pPr algn="ctr">
+              <a:lnSpc>
+                <a:spcPts val="3200"/>
+              </a:lnSpc>
               <a:spcBef>
                 <a:spcPts val="0"/>
               </a:spcBef>
@@ -12526,12 +12988,15 @@
           <a:noFill/>
         </p:spPr>
         <p:txBody>
-          <a:bodyPr wrap="square">
-            <a:spAutoFit/>
+          <a:bodyPr wrap="square" lIns="36576" rIns="36576" tIns="18288" bIns="18288">
+            <a:normAutofit/>
           </a:bodyPr>
           <a:lstStyle/>
           <a:p>
             <a:pPr algn="ctr">
+              <a:lnSpc>
+                <a:spcPts val="2100"/>
+              </a:lnSpc>
               <a:spcBef>
                 <a:spcPts val="0"/>
               </a:spcBef>
@@ -12568,14 +13033,20 @@
           <a:noFill/>
         </p:spPr>
         <p:txBody>
-          <a:bodyPr wrap="square">
-            <a:spAutoFit/>
+          <a:bodyPr wrap="square" lIns="36576" rIns="36576" tIns="18288" bIns="18288">
+            <a:normAutofit/>
           </a:bodyPr>
           <a:lstStyle/>
           <a:p>
             <a:pPr algn="ctr">
-              <a:spcAft>
-                <a:spcPts val="520"/>
+              <a:lnSpc>
+                <a:spcPts val="1600"/>
+              </a:lnSpc>
+              <a:spcBef>
+                <a:spcPts val="0"/>
+              </a:spcBef>
+              <a:spcAft>
+                <a:spcPts val="400"/>
               </a:spcAft>
               <a:defRPr sz="1300" b="0">
                 <a:solidFill>
@@ -12590,8 +13061,14 @@
           </a:p>
           <a:p>
             <a:pPr algn="ctr">
-              <a:spcAft>
-                <a:spcPts val="520"/>
+              <a:lnSpc>
+                <a:spcPts val="1600"/>
+              </a:lnSpc>
+              <a:spcBef>
+                <a:spcPts val="0"/>
+              </a:spcBef>
+              <a:spcAft>
+                <a:spcPts val="400"/>
               </a:spcAft>
               <a:defRPr sz="1300" b="0">
                 <a:solidFill>
@@ -12623,12 +13100,15 @@
           <a:noFill/>
         </p:spPr>
         <p:txBody>
-          <a:bodyPr wrap="square">
-            <a:spAutoFit/>
+          <a:bodyPr wrap="square" lIns="36576" rIns="36576" tIns="18288" bIns="18288">
+            <a:normAutofit/>
           </a:bodyPr>
           <a:lstStyle/>
           <a:p>
             <a:pPr algn="ctr">
+              <a:lnSpc>
+                <a:spcPts val="2200"/>
+              </a:lnSpc>
               <a:spcBef>
                 <a:spcPts val="0"/>
               </a:spcBef>
@@ -12751,12 +13231,15 @@
           <a:noFill/>
         </p:spPr>
         <p:txBody>
-          <a:bodyPr wrap="square">
-            <a:spAutoFit/>
+          <a:bodyPr wrap="square" lIns="36576" rIns="36576" tIns="18288" bIns="18288">
+            <a:normAutofit/>
           </a:bodyPr>
           <a:lstStyle/>
           <a:p>
             <a:pPr algn="ctr">
+              <a:lnSpc>
+                <a:spcPts val="3200"/>
+              </a:lnSpc>
               <a:spcBef>
                 <a:spcPts val="0"/>
               </a:spcBef>
@@ -12793,12 +13276,15 @@
           <a:noFill/>
         </p:spPr>
         <p:txBody>
-          <a:bodyPr wrap="square">
-            <a:spAutoFit/>
+          <a:bodyPr wrap="square" lIns="36576" rIns="36576" tIns="18288" bIns="18288">
+            <a:normAutofit/>
           </a:bodyPr>
           <a:lstStyle/>
           <a:p>
             <a:pPr algn="ctr">
+              <a:lnSpc>
+                <a:spcPts val="2100"/>
+              </a:lnSpc>
               <a:spcBef>
                 <a:spcPts val="0"/>
               </a:spcBef>
@@ -12835,14 +13321,20 @@
           <a:noFill/>
         </p:spPr>
         <p:txBody>
-          <a:bodyPr wrap="square">
-            <a:spAutoFit/>
+          <a:bodyPr wrap="square" lIns="36576" rIns="36576" tIns="18288" bIns="18288">
+            <a:normAutofit/>
           </a:bodyPr>
           <a:lstStyle/>
           <a:p>
             <a:pPr algn="ctr">
-              <a:spcAft>
-                <a:spcPts val="520"/>
+              <a:lnSpc>
+                <a:spcPts val="1600"/>
+              </a:lnSpc>
+              <a:spcBef>
+                <a:spcPts val="0"/>
+              </a:spcBef>
+              <a:spcAft>
+                <a:spcPts val="400"/>
               </a:spcAft>
               <a:defRPr sz="1300" b="0">
                 <a:solidFill>
@@ -12857,8 +13349,14 @@
           </a:p>
           <a:p>
             <a:pPr algn="ctr">
-              <a:spcAft>
-                <a:spcPts val="520"/>
+              <a:lnSpc>
+                <a:spcPts val="1600"/>
+              </a:lnSpc>
+              <a:spcBef>
+                <a:spcPts val="0"/>
+              </a:spcBef>
+              <a:spcAft>
+                <a:spcPts val="400"/>
               </a:spcAft>
               <a:defRPr sz="1300" b="0">
                 <a:solidFill>
@@ -12890,12 +13388,15 @@
           <a:noFill/>
         </p:spPr>
         <p:txBody>
-          <a:bodyPr wrap="square">
-            <a:spAutoFit/>
+          <a:bodyPr wrap="square" lIns="36576" rIns="36576" tIns="18288" bIns="18288">
+            <a:normAutofit/>
           </a:bodyPr>
           <a:lstStyle/>
           <a:p>
             <a:pPr algn="ctr">
+              <a:lnSpc>
+                <a:spcPts val="2200"/>
+              </a:lnSpc>
               <a:spcBef>
                 <a:spcPts val="0"/>
               </a:spcBef>
@@ -13018,12 +13519,15 @@
           <a:noFill/>
         </p:spPr>
         <p:txBody>
-          <a:bodyPr wrap="square">
-            <a:spAutoFit/>
+          <a:bodyPr wrap="square" lIns="36576" rIns="36576" tIns="18288" bIns="18288">
+            <a:normAutofit/>
           </a:bodyPr>
           <a:lstStyle/>
           <a:p>
             <a:pPr algn="ctr">
+              <a:lnSpc>
+                <a:spcPts val="3200"/>
+              </a:lnSpc>
               <a:spcBef>
                 <a:spcPts val="0"/>
               </a:spcBef>
@@ -13060,12 +13564,15 @@
           <a:noFill/>
         </p:spPr>
         <p:txBody>
-          <a:bodyPr wrap="square">
-            <a:spAutoFit/>
+          <a:bodyPr wrap="square" lIns="36576" rIns="36576" tIns="18288" bIns="18288">
+            <a:normAutofit/>
           </a:bodyPr>
           <a:lstStyle/>
           <a:p>
             <a:pPr algn="ctr">
+              <a:lnSpc>
+                <a:spcPts val="2100"/>
+              </a:lnSpc>
               <a:spcBef>
                 <a:spcPts val="0"/>
               </a:spcBef>
@@ -13102,14 +13609,20 @@
           <a:noFill/>
         </p:spPr>
         <p:txBody>
-          <a:bodyPr wrap="square">
-            <a:spAutoFit/>
+          <a:bodyPr wrap="square" lIns="36576" rIns="36576" tIns="18288" bIns="18288">
+            <a:normAutofit/>
           </a:bodyPr>
           <a:lstStyle/>
           <a:p>
             <a:pPr algn="ctr">
-              <a:spcAft>
-                <a:spcPts val="520"/>
+              <a:lnSpc>
+                <a:spcPts val="1600"/>
+              </a:lnSpc>
+              <a:spcBef>
+                <a:spcPts val="0"/>
+              </a:spcBef>
+              <a:spcAft>
+                <a:spcPts val="400"/>
               </a:spcAft>
               <a:defRPr sz="1300" b="0">
                 <a:solidFill>
@@ -13124,8 +13637,14 @@
           </a:p>
           <a:p>
             <a:pPr algn="ctr">
-              <a:spcAft>
-                <a:spcPts val="520"/>
+              <a:lnSpc>
+                <a:spcPts val="1600"/>
+              </a:lnSpc>
+              <a:spcBef>
+                <a:spcPts val="0"/>
+              </a:spcBef>
+              <a:spcAft>
+                <a:spcPts val="400"/>
               </a:spcAft>
               <a:defRPr sz="1300" b="0">
                 <a:solidFill>
@@ -13157,12 +13676,15 @@
           <a:noFill/>
         </p:spPr>
         <p:txBody>
-          <a:bodyPr wrap="square">
-            <a:spAutoFit/>
+          <a:bodyPr wrap="square" lIns="36576" rIns="36576" tIns="18288" bIns="18288">
+            <a:normAutofit/>
           </a:bodyPr>
           <a:lstStyle/>
           <a:p>
             <a:pPr algn="ctr">
+              <a:lnSpc>
+                <a:spcPts val="2200"/>
+              </a:lnSpc>
               <a:spcBef>
                 <a:spcPts val="0"/>
               </a:spcBef>
@@ -13285,12 +13807,15 @@
           <a:noFill/>
         </p:spPr>
         <p:txBody>
-          <a:bodyPr wrap="square">
-            <a:spAutoFit/>
+          <a:bodyPr wrap="square" lIns="36576" rIns="36576" tIns="18288" bIns="18288">
+            <a:normAutofit/>
           </a:bodyPr>
           <a:lstStyle/>
           <a:p>
             <a:pPr algn="ctr">
+              <a:lnSpc>
+                <a:spcPts val="3200"/>
+              </a:lnSpc>
               <a:spcBef>
                 <a:spcPts val="0"/>
               </a:spcBef>
@@ -13327,12 +13852,15 @@
           <a:noFill/>
         </p:spPr>
         <p:txBody>
-          <a:bodyPr wrap="square">
-            <a:spAutoFit/>
+          <a:bodyPr wrap="square" lIns="36576" rIns="36576" tIns="18288" bIns="18288">
+            <a:normAutofit/>
           </a:bodyPr>
           <a:lstStyle/>
           <a:p>
             <a:pPr algn="ctr">
+              <a:lnSpc>
+                <a:spcPts val="2100"/>
+              </a:lnSpc>
               <a:spcBef>
                 <a:spcPts val="0"/>
               </a:spcBef>
@@ -13369,14 +13897,20 @@
           <a:noFill/>
         </p:spPr>
         <p:txBody>
-          <a:bodyPr wrap="square">
-            <a:spAutoFit/>
+          <a:bodyPr wrap="square" lIns="36576" rIns="36576" tIns="18288" bIns="18288">
+            <a:normAutofit/>
           </a:bodyPr>
           <a:lstStyle/>
           <a:p>
             <a:pPr algn="ctr">
-              <a:spcAft>
-                <a:spcPts val="520"/>
+              <a:lnSpc>
+                <a:spcPts val="1600"/>
+              </a:lnSpc>
+              <a:spcBef>
+                <a:spcPts val="0"/>
+              </a:spcBef>
+              <a:spcAft>
+                <a:spcPts val="400"/>
               </a:spcAft>
               <a:defRPr sz="1300" b="0">
                 <a:solidFill>
@@ -13391,8 +13925,14 @@
           </a:p>
           <a:p>
             <a:pPr algn="ctr">
-              <a:spcAft>
-                <a:spcPts val="520"/>
+              <a:lnSpc>
+                <a:spcPts val="1600"/>
+              </a:lnSpc>
+              <a:spcBef>
+                <a:spcPts val="0"/>
+              </a:spcBef>
+              <a:spcAft>
+                <a:spcPts val="400"/>
               </a:spcAft>
               <a:defRPr sz="1300" b="0">
                 <a:solidFill>
@@ -13424,12 +13964,15 @@
           <a:noFill/>
         </p:spPr>
         <p:txBody>
-          <a:bodyPr wrap="square">
-            <a:spAutoFit/>
+          <a:bodyPr wrap="square" lIns="36576" rIns="36576" tIns="18288" bIns="18288">
+            <a:normAutofit/>
           </a:bodyPr>
           <a:lstStyle/>
           <a:p>
             <a:pPr algn="ctr">
+              <a:lnSpc>
+                <a:spcPts val="1700"/>
+              </a:lnSpc>
               <a:spcBef>
                 <a:spcPts val="0"/>
               </a:spcBef>

</xml_diff>

<commit_message>
Fix remaining text spacing issues in pitch deck
Two root causes fixed:
1. Absolute Pt() line spacing doesn't scale when TEXT_TO_FIT_SHAPE
   shrinks fonts — switched to proportional 1.0 line spacing
2. Many heading boxes too small for their font size (34-38pt text
   in 0.7" boxes that need 1.2" when text wraps to 2 lines)

Specific fixes across all 11 slides:
- Heading fonts: 38pt -> 34pt, box heights: 0.7" -> 1.2"
- Tech stack/demo headings: 36pt -> 32pt, heights -> 1.0"
- Slide 7 stat labels: 15pt -> 14pt, height 0.5" -> 0.7"
- Slide 8 diff titles: 15pt -> 14pt, width 3.5" -> 4.0"
- Slide 9 step titles: 17pt -> 15pt, height 0.45" -> 0.55"
- Slide 11 closing: 44pt -> 38pt, height 1.0" -> 1.4"
- add_para_text space_after: Pt(size*0.35) -> fixed Pt(3)

https://claude.ai/code/session_01PtY49K7bv5r2r99EhAAhgg
</commit_message>
<xml_diff>
--- a/MakeItSo_Pitch_Deck.pptx
+++ b/MakeItSo_Pitch_Deck.pptx
@@ -3302,7 +3302,7 @@
           <a:p>
             <a:pPr algn="ctr">
               <a:lnSpc>
-                <a:spcPts val="4500"/>
+                <a:spcPct val="100000"/>
               </a:lnSpc>
               <a:spcBef>
                 <a:spcPts val="0"/>
@@ -3347,7 +3347,7 @@
           <a:p>
             <a:pPr algn="ctr">
               <a:lnSpc>
-                <a:spcPts val="7500"/>
+                <a:spcPct val="100000"/>
               </a:lnSpc>
               <a:spcBef>
                 <a:spcPts val="0"/>
@@ -3392,7 +3392,7 @@
           <a:p>
             <a:pPr algn="ctr">
               <a:lnSpc>
-                <a:spcPts val="2700"/>
+                <a:spcPct val="100000"/>
               </a:lnSpc>
               <a:spcBef>
                 <a:spcPts val="0"/>
@@ -3437,7 +3437,7 @@
           <a:p>
             <a:pPr algn="ctr">
               <a:lnSpc>
-                <a:spcPts val="1700"/>
+                <a:spcPct val="100000"/>
               </a:lnSpc>
               <a:spcBef>
                 <a:spcPts val="0"/>
@@ -3551,7 +3551,7 @@
           <a:p>
             <a:pPr algn="l">
               <a:lnSpc>
-                <a:spcPts val="1600"/>
+                <a:spcPct val="100000"/>
               </a:lnSpc>
               <a:spcBef>
                 <a:spcPts val="0"/>
@@ -3580,8 +3580,8 @@
         </p:nvSpPr>
         <p:spPr>
           <a:xfrm>
-            <a:off x="731520" y="1005840"/>
-            <a:ext cx="10058400" cy="640080"/>
+            <a:off x="731520" y="914400"/>
+            <a:ext cx="10515600" cy="1097280"/>
           </a:xfrm>
           <a:prstGeom prst="rect">
             <a:avLst/>
@@ -3596,15 +3596,15 @@
           <a:p>
             <a:pPr algn="l">
               <a:lnSpc>
-                <a:spcPts val="4700"/>
-              </a:lnSpc>
-              <a:spcBef>
-                <a:spcPts val="0"/>
-              </a:spcBef>
-              <a:spcAft>
-                <a:spcPts val="0"/>
-              </a:spcAft>
-              <a:defRPr sz="3800" b="1">
+                <a:spcPct val="100000"/>
+              </a:lnSpc>
+              <a:spcBef>
+                <a:spcPts val="0"/>
+              </a:spcBef>
+              <a:spcAft>
+                <a:spcPts val="0"/>
+              </a:spcAft>
+              <a:defRPr sz="3400" b="1">
                 <a:solidFill>
                   <a:srgbClr val="1E2A38"/>
                 </a:solidFill>
@@ -3770,7 +3770,7 @@
           <a:p>
             <a:pPr algn="ctr">
               <a:lnSpc>
-                <a:spcPts val="1600"/>
+                <a:spcPct val="100000"/>
               </a:lnSpc>
               <a:spcBef>
                 <a:spcPts val="0"/>
@@ -3815,7 +3815,7 @@
           <a:p>
             <a:pPr algn="l">
               <a:lnSpc>
-                <a:spcPts val="2300"/>
+                <a:spcPct val="100000"/>
               </a:lnSpc>
               <a:spcBef>
                 <a:spcPts val="0"/>
@@ -3860,7 +3860,7 @@
           <a:p>
             <a:pPr algn="l">
               <a:lnSpc>
-                <a:spcPts val="1700"/>
+                <a:spcPct val="100000"/>
               </a:lnSpc>
               <a:spcBef>
                 <a:spcPts val="0"/>
@@ -4034,7 +4034,7 @@
           <a:p>
             <a:pPr algn="ctr">
               <a:lnSpc>
-                <a:spcPts val="1600"/>
+                <a:spcPct val="100000"/>
               </a:lnSpc>
               <a:spcBef>
                 <a:spcPts val="0"/>
@@ -4079,7 +4079,7 @@
           <a:p>
             <a:pPr algn="l">
               <a:lnSpc>
-                <a:spcPts val="2300"/>
+                <a:spcPct val="100000"/>
               </a:lnSpc>
               <a:spcBef>
                 <a:spcPts val="0"/>
@@ -4124,7 +4124,7 @@
           <a:p>
             <a:pPr algn="l">
               <a:lnSpc>
-                <a:spcPts val="1700"/>
+                <a:spcPct val="100000"/>
               </a:lnSpc>
               <a:spcBef>
                 <a:spcPts val="0"/>
@@ -4298,7 +4298,7 @@
           <a:p>
             <a:pPr algn="ctr">
               <a:lnSpc>
-                <a:spcPts val="1600"/>
+                <a:spcPct val="100000"/>
               </a:lnSpc>
               <a:spcBef>
                 <a:spcPts val="0"/>
@@ -4343,7 +4343,7 @@
           <a:p>
             <a:pPr algn="l">
               <a:lnSpc>
-                <a:spcPts val="2300"/>
+                <a:spcPct val="100000"/>
               </a:lnSpc>
               <a:spcBef>
                 <a:spcPts val="0"/>
@@ -4388,7 +4388,7 @@
           <a:p>
             <a:pPr algn="l">
               <a:lnSpc>
-                <a:spcPts val="1700"/>
+                <a:spcPct val="100000"/>
               </a:lnSpc>
               <a:spcBef>
                 <a:spcPts val="0"/>
@@ -4631,7 +4631,7 @@
           <a:p>
             <a:pPr algn="ctr">
               <a:lnSpc>
-                <a:spcPts val="4500"/>
+                <a:spcPct val="100000"/>
               </a:lnSpc>
               <a:spcBef>
                 <a:spcPts val="0"/>
@@ -4660,8 +4660,8 @@
         </p:nvSpPr>
         <p:spPr>
           <a:xfrm>
-            <a:off x="1371600" y="2926080"/>
-            <a:ext cx="9418320" cy="914400"/>
+            <a:off x="1371600" y="2743200"/>
+            <a:ext cx="9418320" cy="1280160"/>
           </a:xfrm>
           <a:prstGeom prst="rect">
             <a:avLst/>
@@ -4676,15 +4676,15 @@
           <a:p>
             <a:pPr algn="ctr">
               <a:lnSpc>
-                <a:spcPts val="5500"/>
-              </a:lnSpc>
-              <a:spcBef>
-                <a:spcPts val="0"/>
-              </a:spcBef>
-              <a:spcAft>
-                <a:spcPts val="0"/>
-              </a:spcAft>
-              <a:defRPr sz="4400" b="1">
+                <a:spcPct val="100000"/>
+              </a:lnSpc>
+              <a:spcBef>
+                <a:spcPts val="0"/>
+              </a:spcBef>
+              <a:spcAft>
+                <a:spcPts val="0"/>
+              </a:spcAft>
+              <a:defRPr sz="3800" b="1">
                 <a:solidFill>
                   <a:srgbClr val="FFFFFF"/>
                 </a:solidFill>
@@ -4721,7 +4721,7 @@
           <a:p>
             <a:pPr algn="ctr">
               <a:lnSpc>
-                <a:spcPts val="2200"/>
+                <a:spcPct val="100000"/>
               </a:lnSpc>
               <a:spcBef>
                 <a:spcPts val="0"/>
@@ -4809,7 +4809,7 @@
           <a:p>
             <a:pPr algn="ctr">
               <a:lnSpc>
-                <a:spcPts val="2200"/>
+                <a:spcPct val="100000"/>
               </a:lnSpc>
               <a:spcBef>
                 <a:spcPts val="0"/>
@@ -4854,7 +4854,7 @@
           <a:p>
             <a:pPr algn="ctr">
               <a:lnSpc>
-                <a:spcPts val="1700"/>
+                <a:spcPct val="100000"/>
               </a:lnSpc>
               <a:spcBef>
                 <a:spcPts val="0"/>
@@ -4968,7 +4968,7 @@
           <a:p>
             <a:pPr algn="l">
               <a:lnSpc>
-                <a:spcPts val="1600"/>
+                <a:spcPct val="100000"/>
               </a:lnSpc>
               <a:spcBef>
                 <a:spcPts val="0"/>
@@ -4997,8 +4997,8 @@
         </p:nvSpPr>
         <p:spPr>
           <a:xfrm>
-            <a:off x="731520" y="1005840"/>
-            <a:ext cx="10058400" cy="640080"/>
+            <a:off x="731520" y="914400"/>
+            <a:ext cx="10515600" cy="1097280"/>
           </a:xfrm>
           <a:prstGeom prst="rect">
             <a:avLst/>
@@ -5013,15 +5013,15 @@
           <a:p>
             <a:pPr algn="l">
               <a:lnSpc>
-                <a:spcPts val="4700"/>
-              </a:lnSpc>
-              <a:spcBef>
-                <a:spcPts val="0"/>
-              </a:spcBef>
-              <a:spcAft>
-                <a:spcPts val="0"/>
-              </a:spcAft>
-              <a:defRPr sz="3800" b="1">
+                <a:spcPct val="100000"/>
+              </a:lnSpc>
+              <a:spcBef>
+                <a:spcPts val="0"/>
+              </a:spcBef>
+              <a:spcAft>
+                <a:spcPts val="0"/>
+              </a:spcAft>
+              <a:defRPr sz="3400" b="1">
                 <a:solidFill>
                   <a:srgbClr val="1E2A38"/>
                 </a:solidFill>
@@ -5043,7 +5043,7 @@
         <p:spPr>
           <a:xfrm>
             <a:off x="731520" y="2194560"/>
-            <a:ext cx="2606040" cy="3657600"/>
+            <a:ext cx="2606040" cy="3931920"/>
           </a:xfrm>
           <a:prstGeom prst="roundRect">
             <a:avLst/>
@@ -5144,7 +5144,7 @@
           <a:p>
             <a:pPr algn="ctr">
               <a:lnSpc>
-                <a:spcPts val="2700"/>
+                <a:spcPct val="100000"/>
               </a:lnSpc>
               <a:spcBef>
                 <a:spcPts val="0"/>
@@ -5174,7 +5174,7 @@
         <p:spPr>
           <a:xfrm>
             <a:off x="960120" y="3337560"/>
-            <a:ext cx="2148840" cy="457200"/>
+            <a:ext cx="2148840" cy="640080"/>
           </a:xfrm>
           <a:prstGeom prst="rect">
             <a:avLst/>
@@ -5189,15 +5189,15 @@
           <a:p>
             <a:pPr algn="ctr">
               <a:lnSpc>
-                <a:spcPts val="2100"/>
-              </a:lnSpc>
-              <a:spcBef>
-                <a:spcPts val="0"/>
-              </a:spcBef>
-              <a:spcAft>
-                <a:spcPts val="0"/>
-              </a:spcAft>
-              <a:defRPr sz="1700" b="1">
+                <a:spcPct val="100000"/>
+              </a:lnSpc>
+              <a:spcBef>
+                <a:spcPts val="0"/>
+              </a:spcBef>
+              <a:spcAft>
+                <a:spcPts val="0"/>
+              </a:spcAft>
+              <a:defRPr sz="1600" b="1">
                 <a:solidFill>
                   <a:srgbClr val="1E2A38"/>
                 </a:solidFill>
@@ -5218,8 +5218,8 @@
         </p:nvSpPr>
         <p:spPr>
           <a:xfrm>
-            <a:off x="960120" y="3931920"/>
-            <a:ext cx="2148840" cy="1645920"/>
+            <a:off x="960120" y="4069079"/>
+            <a:ext cx="2148840" cy="1737360"/>
           </a:xfrm>
           <a:prstGeom prst="rect">
             <a:avLst/>
@@ -5234,7 +5234,7 @@
           <a:p>
             <a:pPr algn="ctr">
               <a:lnSpc>
-                <a:spcPts val="1600"/>
+                <a:spcPct val="100000"/>
               </a:lnSpc>
               <a:spcBef>
                 <a:spcPts val="0"/>
@@ -5264,7 +5264,7 @@
         <p:spPr>
           <a:xfrm>
             <a:off x="3566160" y="2194560"/>
-            <a:ext cx="2606040" cy="3657600"/>
+            <a:ext cx="2606040" cy="3931920"/>
           </a:xfrm>
           <a:prstGeom prst="roundRect">
             <a:avLst/>
@@ -5365,7 +5365,7 @@
           <a:p>
             <a:pPr algn="ctr">
               <a:lnSpc>
-                <a:spcPts val="2700"/>
+                <a:spcPct val="100000"/>
               </a:lnSpc>
               <a:spcBef>
                 <a:spcPts val="0"/>
@@ -5395,7 +5395,7 @@
         <p:spPr>
           <a:xfrm>
             <a:off x="3794760" y="3337560"/>
-            <a:ext cx="2148840" cy="457200"/>
+            <a:ext cx="2148840" cy="640080"/>
           </a:xfrm>
           <a:prstGeom prst="rect">
             <a:avLst/>
@@ -5410,15 +5410,15 @@
           <a:p>
             <a:pPr algn="ctr">
               <a:lnSpc>
-                <a:spcPts val="2100"/>
-              </a:lnSpc>
-              <a:spcBef>
-                <a:spcPts val="0"/>
-              </a:spcBef>
-              <a:spcAft>
-                <a:spcPts val="0"/>
-              </a:spcAft>
-              <a:defRPr sz="1700" b="1">
+                <a:spcPct val="100000"/>
+              </a:lnSpc>
+              <a:spcBef>
+                <a:spcPts val="0"/>
+              </a:spcBef>
+              <a:spcAft>
+                <a:spcPts val="0"/>
+              </a:spcAft>
+              <a:defRPr sz="1600" b="1">
                 <a:solidFill>
                   <a:srgbClr val="1E2A38"/>
                 </a:solidFill>
@@ -5439,8 +5439,8 @@
         </p:nvSpPr>
         <p:spPr>
           <a:xfrm>
-            <a:off x="3794760" y="3931920"/>
-            <a:ext cx="2148840" cy="1645920"/>
+            <a:off x="3794760" y="4069079"/>
+            <a:ext cx="2148840" cy="1737360"/>
           </a:xfrm>
           <a:prstGeom prst="rect">
             <a:avLst/>
@@ -5455,7 +5455,7 @@
           <a:p>
             <a:pPr algn="ctr">
               <a:lnSpc>
-                <a:spcPts val="1600"/>
+                <a:spcPct val="100000"/>
               </a:lnSpc>
               <a:spcBef>
                 <a:spcPts val="0"/>
@@ -5485,7 +5485,7 @@
         <p:spPr>
           <a:xfrm>
             <a:off x="6400800" y="2194560"/>
-            <a:ext cx="2606040" cy="3657600"/>
+            <a:ext cx="2606040" cy="3931920"/>
           </a:xfrm>
           <a:prstGeom prst="roundRect">
             <a:avLst/>
@@ -5586,7 +5586,7 @@
           <a:p>
             <a:pPr algn="ctr">
               <a:lnSpc>
-                <a:spcPts val="2700"/>
+                <a:spcPct val="100000"/>
               </a:lnSpc>
               <a:spcBef>
                 <a:spcPts val="0"/>
@@ -5616,7 +5616,7 @@
         <p:spPr>
           <a:xfrm>
             <a:off x="6629400" y="3337560"/>
-            <a:ext cx="2148840" cy="457200"/>
+            <a:ext cx="2148840" cy="640080"/>
           </a:xfrm>
           <a:prstGeom prst="rect">
             <a:avLst/>
@@ -5631,15 +5631,15 @@
           <a:p>
             <a:pPr algn="ctr">
               <a:lnSpc>
-                <a:spcPts val="2100"/>
-              </a:lnSpc>
-              <a:spcBef>
-                <a:spcPts val="0"/>
-              </a:spcBef>
-              <a:spcAft>
-                <a:spcPts val="0"/>
-              </a:spcAft>
-              <a:defRPr sz="1700" b="1">
+                <a:spcPct val="100000"/>
+              </a:lnSpc>
+              <a:spcBef>
+                <a:spcPts val="0"/>
+              </a:spcBef>
+              <a:spcAft>
+                <a:spcPts val="0"/>
+              </a:spcAft>
+              <a:defRPr sz="1600" b="1">
                 <a:solidFill>
                   <a:srgbClr val="1E2A38"/>
                 </a:solidFill>
@@ -5660,8 +5660,8 @@
         </p:nvSpPr>
         <p:spPr>
           <a:xfrm>
-            <a:off x="6629400" y="3931920"/>
-            <a:ext cx="2148840" cy="1645920"/>
+            <a:off x="6629400" y="4069079"/>
+            <a:ext cx="2148840" cy="1737360"/>
           </a:xfrm>
           <a:prstGeom prst="rect">
             <a:avLst/>
@@ -5676,7 +5676,7 @@
           <a:p>
             <a:pPr algn="ctr">
               <a:lnSpc>
-                <a:spcPts val="1600"/>
+                <a:spcPct val="100000"/>
               </a:lnSpc>
               <a:spcBef>
                 <a:spcPts val="0"/>
@@ -5706,7 +5706,7 @@
         <p:spPr>
           <a:xfrm>
             <a:off x="9235440" y="2194560"/>
-            <a:ext cx="2606040" cy="3657600"/>
+            <a:ext cx="2606040" cy="3931920"/>
           </a:xfrm>
           <a:prstGeom prst="roundRect">
             <a:avLst/>
@@ -5807,7 +5807,7 @@
           <a:p>
             <a:pPr algn="ctr">
               <a:lnSpc>
-                <a:spcPts val="2700"/>
+                <a:spcPct val="100000"/>
               </a:lnSpc>
               <a:spcBef>
                 <a:spcPts val="0"/>
@@ -5837,7 +5837,7 @@
         <p:spPr>
           <a:xfrm>
             <a:off x="9464040" y="3337560"/>
-            <a:ext cx="2148840" cy="457200"/>
+            <a:ext cx="2148840" cy="640080"/>
           </a:xfrm>
           <a:prstGeom prst="rect">
             <a:avLst/>
@@ -5852,15 +5852,15 @@
           <a:p>
             <a:pPr algn="ctr">
               <a:lnSpc>
-                <a:spcPts val="2100"/>
-              </a:lnSpc>
-              <a:spcBef>
-                <a:spcPts val="0"/>
-              </a:spcBef>
-              <a:spcAft>
-                <a:spcPts val="0"/>
-              </a:spcAft>
-              <a:defRPr sz="1700" b="1">
+                <a:spcPct val="100000"/>
+              </a:lnSpc>
+              <a:spcBef>
+                <a:spcPts val="0"/>
+              </a:spcBef>
+              <a:spcAft>
+                <a:spcPts val="0"/>
+              </a:spcAft>
+              <a:defRPr sz="1600" b="1">
                 <a:solidFill>
                   <a:srgbClr val="1E2A38"/>
                 </a:solidFill>
@@ -5881,8 +5881,8 @@
         </p:nvSpPr>
         <p:spPr>
           <a:xfrm>
-            <a:off x="9464040" y="3931920"/>
-            <a:ext cx="2148840" cy="1645920"/>
+            <a:off x="9464040" y="4069079"/>
+            <a:ext cx="2148840" cy="1737360"/>
           </a:xfrm>
           <a:prstGeom prst="rect">
             <a:avLst/>
@@ -5897,7 +5897,7 @@
           <a:p>
             <a:pPr algn="ctr">
               <a:lnSpc>
-                <a:spcPts val="1600"/>
+                <a:spcPct val="100000"/>
               </a:lnSpc>
               <a:spcBef>
                 <a:spcPts val="0"/>
@@ -6011,7 +6011,7 @@
           <a:p>
             <a:pPr algn="l">
               <a:lnSpc>
-                <a:spcPts val="1600"/>
+                <a:spcPct val="100000"/>
               </a:lnSpc>
               <a:spcBef>
                 <a:spcPts val="0"/>
@@ -6040,8 +6040,8 @@
         </p:nvSpPr>
         <p:spPr>
           <a:xfrm>
-            <a:off x="731520" y="1005840"/>
-            <a:ext cx="10058400" cy="640080"/>
+            <a:off x="731520" y="914400"/>
+            <a:ext cx="10515600" cy="1097280"/>
           </a:xfrm>
           <a:prstGeom prst="rect">
             <a:avLst/>
@@ -6056,15 +6056,15 @@
           <a:p>
             <a:pPr algn="l">
               <a:lnSpc>
-                <a:spcPts val="4700"/>
-              </a:lnSpc>
-              <a:spcBef>
-                <a:spcPts val="0"/>
-              </a:spcBef>
-              <a:spcAft>
-                <a:spcPts val="0"/>
-              </a:spcAft>
-              <a:defRPr sz="3800" b="1">
+                <a:spcPct val="100000"/>
+              </a:lnSpc>
+              <a:spcBef>
+                <a:spcPts val="0"/>
+              </a:spcBef>
+              <a:spcAft>
+                <a:spcPts val="0"/>
+              </a:spcAft>
+              <a:defRPr sz="3400" b="1">
                 <a:solidFill>
                   <a:srgbClr val="1E2A38"/>
                 </a:solidFill>
@@ -6101,7 +6101,7 @@
           <a:p>
             <a:pPr algn="l">
               <a:lnSpc>
-                <a:spcPts val="2000"/>
+                <a:spcPct val="100000"/>
               </a:lnSpc>
               <a:spcBef>
                 <a:spcPts val="0"/>
@@ -6232,7 +6232,7 @@
           <a:p>
             <a:pPr algn="l">
               <a:lnSpc>
-                <a:spcPts val="3000"/>
+                <a:spcPct val="100000"/>
               </a:lnSpc>
               <a:spcBef>
                 <a:spcPts val="0"/>
@@ -6277,7 +6277,7 @@
           <a:p>
             <a:pPr algn="l">
               <a:lnSpc>
-                <a:spcPts val="1700"/>
+                <a:spcPct val="100000"/>
               </a:lnSpc>
               <a:spcBef>
                 <a:spcPts val="0"/>
@@ -6365,7 +6365,7 @@
           <a:p>
             <a:pPr algn="ctr">
               <a:lnSpc>
-                <a:spcPts val="1300"/>
+                <a:spcPct val="100000"/>
               </a:lnSpc>
               <a:spcBef>
                 <a:spcPts val="0"/>
@@ -6410,7 +6410,7 @@
           <a:p>
             <a:pPr algn="l">
               <a:lnSpc>
-                <a:spcPts val="1700"/>
+                <a:spcPct val="100000"/>
               </a:lnSpc>
               <a:spcBef>
                 <a:spcPts val="0"/>
@@ -6498,7 +6498,7 @@
           <a:p>
             <a:pPr algn="ctr">
               <a:lnSpc>
-                <a:spcPts val="1300"/>
+                <a:spcPct val="100000"/>
               </a:lnSpc>
               <a:spcBef>
                 <a:spcPts val="0"/>
@@ -6543,7 +6543,7 @@
           <a:p>
             <a:pPr algn="l">
               <a:lnSpc>
-                <a:spcPts val="1700"/>
+                <a:spcPct val="100000"/>
               </a:lnSpc>
               <a:spcBef>
                 <a:spcPts val="0"/>
@@ -6631,7 +6631,7 @@
           <a:p>
             <a:pPr algn="ctr">
               <a:lnSpc>
-                <a:spcPts val="1300"/>
+                <a:spcPct val="100000"/>
               </a:lnSpc>
               <a:spcBef>
                 <a:spcPts val="0"/>
@@ -6676,7 +6676,7 @@
           <a:p>
             <a:pPr algn="l">
               <a:lnSpc>
-                <a:spcPts val="1700"/>
+                <a:spcPct val="100000"/>
               </a:lnSpc>
               <a:spcBef>
                 <a:spcPts val="0"/>
@@ -6764,7 +6764,7 @@
           <a:p>
             <a:pPr algn="ctr">
               <a:lnSpc>
-                <a:spcPts val="1300"/>
+                <a:spcPct val="100000"/>
               </a:lnSpc>
               <a:spcBef>
                 <a:spcPts val="0"/>
@@ -6809,7 +6809,7 @@
           <a:p>
             <a:pPr algn="l">
               <a:lnSpc>
-                <a:spcPts val="1700"/>
+                <a:spcPct val="100000"/>
               </a:lnSpc>
               <a:spcBef>
                 <a:spcPts val="0"/>
@@ -6940,7 +6940,7 @@
           <a:p>
             <a:pPr algn="l">
               <a:lnSpc>
-                <a:spcPts val="3000"/>
+                <a:spcPct val="100000"/>
               </a:lnSpc>
               <a:spcBef>
                 <a:spcPts val="0"/>
@@ -6985,7 +6985,7 @@
           <a:p>
             <a:pPr algn="l">
               <a:lnSpc>
-                <a:spcPts val="1700"/>
+                <a:spcPct val="100000"/>
               </a:lnSpc>
               <a:spcBef>
                 <a:spcPts val="0"/>
@@ -7073,7 +7073,7 @@
           <a:p>
             <a:pPr algn="ctr">
               <a:lnSpc>
-                <a:spcPts val="1300"/>
+                <a:spcPct val="100000"/>
               </a:lnSpc>
               <a:spcBef>
                 <a:spcPts val="0"/>
@@ -7118,7 +7118,7 @@
           <a:p>
             <a:pPr algn="l">
               <a:lnSpc>
-                <a:spcPts val="1700"/>
+                <a:spcPct val="100000"/>
               </a:lnSpc>
               <a:spcBef>
                 <a:spcPts val="0"/>
@@ -7206,7 +7206,7 @@
           <a:p>
             <a:pPr algn="ctr">
               <a:lnSpc>
-                <a:spcPts val="1300"/>
+                <a:spcPct val="100000"/>
               </a:lnSpc>
               <a:spcBef>
                 <a:spcPts val="0"/>
@@ -7251,7 +7251,7 @@
           <a:p>
             <a:pPr algn="l">
               <a:lnSpc>
-                <a:spcPts val="1700"/>
+                <a:spcPct val="100000"/>
               </a:lnSpc>
               <a:spcBef>
                 <a:spcPts val="0"/>
@@ -7339,7 +7339,7 @@
           <a:p>
             <a:pPr algn="ctr">
               <a:lnSpc>
-                <a:spcPts val="1300"/>
+                <a:spcPct val="100000"/>
               </a:lnSpc>
               <a:spcBef>
                 <a:spcPts val="0"/>
@@ -7384,7 +7384,7 @@
           <a:p>
             <a:pPr algn="l">
               <a:lnSpc>
-                <a:spcPts val="1700"/>
+                <a:spcPct val="100000"/>
               </a:lnSpc>
               <a:spcBef>
                 <a:spcPts val="0"/>
@@ -7472,7 +7472,7 @@
           <a:p>
             <a:pPr algn="ctr">
               <a:lnSpc>
-                <a:spcPts val="1300"/>
+                <a:spcPct val="100000"/>
               </a:lnSpc>
               <a:spcBef>
                 <a:spcPts val="0"/>
@@ -7517,7 +7517,7 @@
           <a:p>
             <a:pPr algn="l">
               <a:lnSpc>
-                <a:spcPts val="1700"/>
+                <a:spcPct val="100000"/>
               </a:lnSpc>
               <a:spcBef>
                 <a:spcPts val="0"/>
@@ -7631,7 +7631,7 @@
           <a:p>
             <a:pPr algn="l">
               <a:lnSpc>
-                <a:spcPts val="1600"/>
+                <a:spcPct val="100000"/>
               </a:lnSpc>
               <a:spcBef>
                 <a:spcPts val="0"/>
@@ -7660,8 +7660,8 @@
         </p:nvSpPr>
         <p:spPr>
           <a:xfrm>
-            <a:off x="731520" y="1005840"/>
-            <a:ext cx="10058400" cy="640080"/>
+            <a:off x="731520" y="914400"/>
+            <a:ext cx="10515600" cy="914400"/>
           </a:xfrm>
           <a:prstGeom prst="rect">
             <a:avLst/>
@@ -7676,15 +7676,15 @@
           <a:p>
             <a:pPr algn="l">
               <a:lnSpc>
-                <a:spcPts val="4700"/>
-              </a:lnSpc>
-              <a:spcBef>
-                <a:spcPts val="0"/>
-              </a:spcBef>
-              <a:spcAft>
-                <a:spcPts val="0"/>
-              </a:spcAft>
-              <a:defRPr sz="3800" b="1">
+                <a:spcPct val="100000"/>
+              </a:lnSpc>
+              <a:spcBef>
+                <a:spcPts val="0"/>
+              </a:spcBef>
+              <a:spcAft>
+                <a:spcPts val="0"/>
+              </a:spcAft>
+              <a:defRPr sz="3400" b="1">
                 <a:solidFill>
                   <a:srgbClr val="1E2A38"/>
                 </a:solidFill>
@@ -7850,7 +7850,7 @@
           <a:p>
             <a:pPr algn="ctr">
               <a:lnSpc>
-                <a:spcPts val="3000"/>
+                <a:spcPct val="100000"/>
               </a:lnSpc>
               <a:spcBef>
                 <a:spcPts val="0"/>
@@ -7895,7 +7895,7 @@
           <a:p>
             <a:pPr algn="ctr">
               <a:lnSpc>
-                <a:spcPts val="2200"/>
+                <a:spcPct val="100000"/>
               </a:lnSpc>
               <a:spcBef>
                 <a:spcPts val="0"/>
@@ -7940,7 +7940,7 @@
           <a:p>
             <a:pPr algn="ctr">
               <a:lnSpc>
-                <a:spcPts val="1600"/>
+                <a:spcPct val="100000"/>
               </a:lnSpc>
               <a:spcBef>
                 <a:spcPts val="0"/>
@@ -8114,7 +8114,7 @@
           <a:p>
             <a:pPr algn="ctr">
               <a:lnSpc>
-                <a:spcPts val="3000"/>
+                <a:spcPct val="100000"/>
               </a:lnSpc>
               <a:spcBef>
                 <a:spcPts val="0"/>
@@ -8159,7 +8159,7 @@
           <a:p>
             <a:pPr algn="ctr">
               <a:lnSpc>
-                <a:spcPts val="2200"/>
+                <a:spcPct val="100000"/>
               </a:lnSpc>
               <a:spcBef>
                 <a:spcPts val="0"/>
@@ -8204,7 +8204,7 @@
           <a:p>
             <a:pPr algn="ctr">
               <a:lnSpc>
-                <a:spcPts val="1600"/>
+                <a:spcPct val="100000"/>
               </a:lnSpc>
               <a:spcBef>
                 <a:spcPts val="0"/>
@@ -8378,7 +8378,7 @@
           <a:p>
             <a:pPr algn="ctr">
               <a:lnSpc>
-                <a:spcPts val="3000"/>
+                <a:spcPct val="100000"/>
               </a:lnSpc>
               <a:spcBef>
                 <a:spcPts val="0"/>
@@ -8423,7 +8423,7 @@
           <a:p>
             <a:pPr algn="ctr">
               <a:lnSpc>
-                <a:spcPts val="2200"/>
+                <a:spcPct val="100000"/>
               </a:lnSpc>
               <a:spcBef>
                 <a:spcPts val="0"/>
@@ -8468,7 +8468,7 @@
           <a:p>
             <a:pPr algn="ctr">
               <a:lnSpc>
-                <a:spcPts val="1600"/>
+                <a:spcPct val="100000"/>
               </a:lnSpc>
               <a:spcBef>
                 <a:spcPts val="0"/>
@@ -8582,7 +8582,7 @@
           <a:p>
             <a:pPr algn="l">
               <a:lnSpc>
-                <a:spcPts val="1600"/>
+                <a:spcPct val="100000"/>
               </a:lnSpc>
               <a:spcBef>
                 <a:spcPts val="0"/>
@@ -8611,8 +8611,8 @@
         </p:nvSpPr>
         <p:spPr>
           <a:xfrm>
-            <a:off x="731520" y="1005840"/>
-            <a:ext cx="10058400" cy="640080"/>
+            <a:off x="731520" y="914400"/>
+            <a:ext cx="10515600" cy="914400"/>
           </a:xfrm>
           <a:prstGeom prst="rect">
             <a:avLst/>
@@ -8627,15 +8627,15 @@
           <a:p>
             <a:pPr algn="l">
               <a:lnSpc>
-                <a:spcPts val="4700"/>
-              </a:lnSpc>
-              <a:spcBef>
-                <a:spcPts val="0"/>
-              </a:spcBef>
-              <a:spcAft>
-                <a:spcPts val="0"/>
-              </a:spcAft>
-              <a:defRPr sz="3800" b="1">
+                <a:spcPct val="100000"/>
+              </a:lnSpc>
+              <a:spcBef>
+                <a:spcPts val="0"/>
+              </a:spcBef>
+              <a:spcAft>
+                <a:spcPts val="0"/>
+              </a:spcAft>
+              <a:defRPr sz="3400" b="1">
                 <a:solidFill>
                   <a:srgbClr val="1E2A38"/>
                 </a:solidFill>
@@ -8801,7 +8801,7 @@
           <a:p>
             <a:pPr algn="ctr">
               <a:lnSpc>
-                <a:spcPts val="3000"/>
+                <a:spcPct val="100000"/>
               </a:lnSpc>
               <a:spcBef>
                 <a:spcPts val="0"/>
@@ -8846,7 +8846,7 @@
           <a:p>
             <a:pPr algn="ctr">
               <a:lnSpc>
-                <a:spcPts val="2200"/>
+                <a:spcPct val="100000"/>
               </a:lnSpc>
               <a:spcBef>
                 <a:spcPts val="0"/>
@@ -8891,7 +8891,7 @@
           <a:p>
             <a:pPr algn="ctr">
               <a:lnSpc>
-                <a:spcPts val="1600"/>
+                <a:spcPct val="100000"/>
               </a:lnSpc>
               <a:spcBef>
                 <a:spcPts val="0"/>
@@ -9065,7 +9065,7 @@
           <a:p>
             <a:pPr algn="ctr">
               <a:lnSpc>
-                <a:spcPts val="3000"/>
+                <a:spcPct val="100000"/>
               </a:lnSpc>
               <a:spcBef>
                 <a:spcPts val="0"/>
@@ -9110,7 +9110,7 @@
           <a:p>
             <a:pPr algn="ctr">
               <a:lnSpc>
-                <a:spcPts val="2200"/>
+                <a:spcPct val="100000"/>
               </a:lnSpc>
               <a:spcBef>
                 <a:spcPts val="0"/>
@@ -9155,7 +9155,7 @@
           <a:p>
             <a:pPr algn="ctr">
               <a:lnSpc>
-                <a:spcPts val="1600"/>
+                <a:spcPct val="100000"/>
               </a:lnSpc>
               <a:spcBef>
                 <a:spcPts val="0"/>
@@ -9329,7 +9329,7 @@
           <a:p>
             <a:pPr algn="ctr">
               <a:lnSpc>
-                <a:spcPts val="3000"/>
+                <a:spcPct val="100000"/>
               </a:lnSpc>
               <a:spcBef>
                 <a:spcPts val="0"/>
@@ -9374,7 +9374,7 @@
           <a:p>
             <a:pPr algn="ctr">
               <a:lnSpc>
-                <a:spcPts val="2200"/>
+                <a:spcPct val="100000"/>
               </a:lnSpc>
               <a:spcBef>
                 <a:spcPts val="0"/>
@@ -9419,7 +9419,7 @@
           <a:p>
             <a:pPr algn="ctr">
               <a:lnSpc>
-                <a:spcPts val="1600"/>
+                <a:spcPct val="100000"/>
               </a:lnSpc>
               <a:spcBef>
                 <a:spcPts val="0"/>
@@ -9533,7 +9533,7 @@
           <a:p>
             <a:pPr algn="l">
               <a:lnSpc>
-                <a:spcPts val="1600"/>
+                <a:spcPct val="100000"/>
               </a:lnSpc>
               <a:spcBef>
                 <a:spcPts val="0"/>
@@ -9562,8 +9562,8 @@
         </p:nvSpPr>
         <p:spPr>
           <a:xfrm>
-            <a:off x="731520" y="914400"/>
-            <a:ext cx="10058400" cy="640080"/>
+            <a:off x="731520" y="822960"/>
+            <a:ext cx="10515600" cy="914400"/>
           </a:xfrm>
           <a:prstGeom prst="rect">
             <a:avLst/>
@@ -9578,15 +9578,15 @@
           <a:p>
             <a:pPr algn="l">
               <a:lnSpc>
-                <a:spcPts val="4500"/>
-              </a:lnSpc>
-              <a:spcBef>
-                <a:spcPts val="0"/>
-              </a:spcBef>
-              <a:spcAft>
-                <a:spcPts val="0"/>
-              </a:spcAft>
-              <a:defRPr sz="3600" b="1">
+                <a:spcPct val="100000"/>
+              </a:lnSpc>
+              <a:spcBef>
+                <a:spcPts val="0"/>
+              </a:spcBef>
+              <a:spcAft>
+                <a:spcPts val="0"/>
+              </a:spcAft>
+              <a:defRPr sz="3200" b="1">
                 <a:solidFill>
                   <a:srgbClr val="FFFFFF"/>
                 </a:solidFill>
@@ -9709,7 +9709,7 @@
           <a:p>
             <a:pPr algn="l">
               <a:lnSpc>
-                <a:spcPts val="2500"/>
+                <a:spcPct val="100000"/>
               </a:lnSpc>
               <a:spcBef>
                 <a:spcPts val="0"/>
@@ -9754,13 +9754,13 @@
           <a:p>
             <a:pPr algn="l">
               <a:lnSpc>
-                <a:spcPts val="1600"/>
-              </a:lnSpc>
-              <a:spcBef>
-                <a:spcPts val="0"/>
-              </a:spcBef>
-              <a:spcAft>
-                <a:spcPts val="400"/>
+                <a:spcPct val="100000"/>
+              </a:lnSpc>
+              <a:spcBef>
+                <a:spcPts val="0"/>
+              </a:spcBef>
+              <a:spcAft>
+                <a:spcPts val="300"/>
               </a:spcAft>
               <a:defRPr sz="1300" b="0">
                 <a:solidFill>
@@ -9776,13 +9776,13 @@
           <a:p>
             <a:pPr algn="l">
               <a:lnSpc>
-                <a:spcPts val="1600"/>
-              </a:lnSpc>
-              <a:spcBef>
-                <a:spcPts val="0"/>
-              </a:spcBef>
-              <a:spcAft>
-                <a:spcPts val="400"/>
+                <a:spcPct val="100000"/>
+              </a:lnSpc>
+              <a:spcBef>
+                <a:spcPts val="0"/>
+              </a:spcBef>
+              <a:spcAft>
+                <a:spcPts val="300"/>
               </a:spcAft>
               <a:defRPr sz="1300" b="0">
                 <a:solidFill>
@@ -9798,13 +9798,13 @@
           <a:p>
             <a:pPr algn="l">
               <a:lnSpc>
-                <a:spcPts val="1600"/>
-              </a:lnSpc>
-              <a:spcBef>
-                <a:spcPts val="0"/>
-              </a:spcBef>
-              <a:spcAft>
-                <a:spcPts val="400"/>
+                <a:spcPct val="100000"/>
+              </a:lnSpc>
+              <a:spcBef>
+                <a:spcPts val="0"/>
+              </a:spcBef>
+              <a:spcAft>
+                <a:spcPts val="300"/>
               </a:spcAft>
               <a:defRPr sz="1300" b="0">
                 <a:solidFill>
@@ -9820,13 +9820,13 @@
           <a:p>
             <a:pPr algn="l">
               <a:lnSpc>
-                <a:spcPts val="1600"/>
-              </a:lnSpc>
-              <a:spcBef>
-                <a:spcPts val="0"/>
-              </a:spcBef>
-              <a:spcAft>
-                <a:spcPts val="400"/>
+                <a:spcPct val="100000"/>
+              </a:lnSpc>
+              <a:spcBef>
+                <a:spcPts val="0"/>
+              </a:spcBef>
+              <a:spcAft>
+                <a:spcPts val="300"/>
               </a:spcAft>
               <a:defRPr sz="1300" b="0">
                 <a:solidFill>
@@ -9951,7 +9951,7 @@
           <a:p>
             <a:pPr algn="l">
               <a:lnSpc>
-                <a:spcPts val="2500"/>
+                <a:spcPct val="100000"/>
               </a:lnSpc>
               <a:spcBef>
                 <a:spcPts val="0"/>
@@ -9996,13 +9996,13 @@
           <a:p>
             <a:pPr algn="l">
               <a:lnSpc>
-                <a:spcPts val="1600"/>
-              </a:lnSpc>
-              <a:spcBef>
-                <a:spcPts val="0"/>
-              </a:spcBef>
-              <a:spcAft>
-                <a:spcPts val="400"/>
+                <a:spcPct val="100000"/>
+              </a:lnSpc>
+              <a:spcBef>
+                <a:spcPts val="0"/>
+              </a:spcBef>
+              <a:spcAft>
+                <a:spcPts val="300"/>
               </a:spcAft>
               <a:defRPr sz="1300" b="0">
                 <a:solidFill>
@@ -10018,13 +10018,13 @@
           <a:p>
             <a:pPr algn="l">
               <a:lnSpc>
-                <a:spcPts val="1600"/>
-              </a:lnSpc>
-              <a:spcBef>
-                <a:spcPts val="0"/>
-              </a:spcBef>
-              <a:spcAft>
-                <a:spcPts val="400"/>
+                <a:spcPct val="100000"/>
+              </a:lnSpc>
+              <a:spcBef>
+                <a:spcPts val="0"/>
+              </a:spcBef>
+              <a:spcAft>
+                <a:spcPts val="300"/>
               </a:spcAft>
               <a:defRPr sz="1300" b="0">
                 <a:solidFill>
@@ -10040,13 +10040,13 @@
           <a:p>
             <a:pPr algn="l">
               <a:lnSpc>
-                <a:spcPts val="1600"/>
-              </a:lnSpc>
-              <a:spcBef>
-                <a:spcPts val="0"/>
-              </a:spcBef>
-              <a:spcAft>
-                <a:spcPts val="400"/>
+                <a:spcPct val="100000"/>
+              </a:lnSpc>
+              <a:spcBef>
+                <a:spcPts val="0"/>
+              </a:spcBef>
+              <a:spcAft>
+                <a:spcPts val="300"/>
               </a:spcAft>
               <a:defRPr sz="1300" b="0">
                 <a:solidFill>
@@ -10062,13 +10062,13 @@
           <a:p>
             <a:pPr algn="l">
               <a:lnSpc>
-                <a:spcPts val="1600"/>
-              </a:lnSpc>
-              <a:spcBef>
-                <a:spcPts val="0"/>
-              </a:spcBef>
-              <a:spcAft>
-                <a:spcPts val="400"/>
+                <a:spcPct val="100000"/>
+              </a:lnSpc>
+              <a:spcBef>
+                <a:spcPts val="0"/>
+              </a:spcBef>
+              <a:spcAft>
+                <a:spcPts val="300"/>
               </a:spcAft>
               <a:defRPr sz="1300" b="0">
                 <a:solidFill>
@@ -10193,7 +10193,7 @@
           <a:p>
             <a:pPr algn="l">
               <a:lnSpc>
-                <a:spcPts val="2500"/>
+                <a:spcPct val="100000"/>
               </a:lnSpc>
               <a:spcBef>
                 <a:spcPts val="0"/>
@@ -10238,13 +10238,13 @@
           <a:p>
             <a:pPr algn="l">
               <a:lnSpc>
-                <a:spcPts val="1600"/>
-              </a:lnSpc>
-              <a:spcBef>
-                <a:spcPts val="0"/>
-              </a:spcBef>
-              <a:spcAft>
-                <a:spcPts val="400"/>
+                <a:spcPct val="100000"/>
+              </a:lnSpc>
+              <a:spcBef>
+                <a:spcPts val="0"/>
+              </a:spcBef>
+              <a:spcAft>
+                <a:spcPts val="300"/>
               </a:spcAft>
               <a:defRPr sz="1300" b="0">
                 <a:solidFill>
@@ -10260,13 +10260,13 @@
           <a:p>
             <a:pPr algn="l">
               <a:lnSpc>
-                <a:spcPts val="1600"/>
-              </a:lnSpc>
-              <a:spcBef>
-                <a:spcPts val="0"/>
-              </a:spcBef>
-              <a:spcAft>
-                <a:spcPts val="400"/>
+                <a:spcPct val="100000"/>
+              </a:lnSpc>
+              <a:spcBef>
+                <a:spcPts val="0"/>
+              </a:spcBef>
+              <a:spcAft>
+                <a:spcPts val="300"/>
               </a:spcAft>
               <a:defRPr sz="1300" b="0">
                 <a:solidFill>
@@ -10282,13 +10282,13 @@
           <a:p>
             <a:pPr algn="l">
               <a:lnSpc>
-                <a:spcPts val="1600"/>
-              </a:lnSpc>
-              <a:spcBef>
-                <a:spcPts val="0"/>
-              </a:spcBef>
-              <a:spcAft>
-                <a:spcPts val="400"/>
+                <a:spcPct val="100000"/>
+              </a:lnSpc>
+              <a:spcBef>
+                <a:spcPts val="0"/>
+              </a:spcBef>
+              <a:spcAft>
+                <a:spcPts val="300"/>
               </a:spcAft>
               <a:defRPr sz="1300" b="0">
                 <a:solidFill>
@@ -10304,13 +10304,13 @@
           <a:p>
             <a:pPr algn="l">
               <a:lnSpc>
-                <a:spcPts val="1600"/>
-              </a:lnSpc>
-              <a:spcBef>
-                <a:spcPts val="0"/>
-              </a:spcBef>
-              <a:spcAft>
-                <a:spcPts val="400"/>
+                <a:spcPct val="100000"/>
+              </a:lnSpc>
+              <a:spcBef>
+                <a:spcPts val="0"/>
+              </a:spcBef>
+              <a:spcAft>
+                <a:spcPts val="300"/>
               </a:spcAft>
               <a:defRPr sz="1300" b="0">
                 <a:solidFill>
@@ -10435,7 +10435,7 @@
           <a:p>
             <a:pPr algn="l">
               <a:lnSpc>
-                <a:spcPts val="2500"/>
+                <a:spcPct val="100000"/>
               </a:lnSpc>
               <a:spcBef>
                 <a:spcPts val="0"/>
@@ -10480,13 +10480,13 @@
           <a:p>
             <a:pPr algn="l">
               <a:lnSpc>
-                <a:spcPts val="1600"/>
-              </a:lnSpc>
-              <a:spcBef>
-                <a:spcPts val="0"/>
-              </a:spcBef>
-              <a:spcAft>
-                <a:spcPts val="400"/>
+                <a:spcPct val="100000"/>
+              </a:lnSpc>
+              <a:spcBef>
+                <a:spcPts val="0"/>
+              </a:spcBef>
+              <a:spcAft>
+                <a:spcPts val="300"/>
               </a:spcAft>
               <a:defRPr sz="1300" b="0">
                 <a:solidFill>
@@ -10502,13 +10502,13 @@
           <a:p>
             <a:pPr algn="l">
               <a:lnSpc>
-                <a:spcPts val="1600"/>
-              </a:lnSpc>
-              <a:spcBef>
-                <a:spcPts val="0"/>
-              </a:spcBef>
-              <a:spcAft>
-                <a:spcPts val="400"/>
+                <a:spcPct val="100000"/>
+              </a:lnSpc>
+              <a:spcBef>
+                <a:spcPts val="0"/>
+              </a:spcBef>
+              <a:spcAft>
+                <a:spcPts val="300"/>
               </a:spcAft>
               <a:defRPr sz="1300" b="0">
                 <a:solidFill>
@@ -10524,13 +10524,13 @@
           <a:p>
             <a:pPr algn="l">
               <a:lnSpc>
-                <a:spcPts val="1600"/>
-              </a:lnSpc>
-              <a:spcBef>
-                <a:spcPts val="0"/>
-              </a:spcBef>
-              <a:spcAft>
-                <a:spcPts val="400"/>
+                <a:spcPct val="100000"/>
+              </a:lnSpc>
+              <a:spcBef>
+                <a:spcPts val="0"/>
+              </a:spcBef>
+              <a:spcAft>
+                <a:spcPts val="300"/>
               </a:spcAft>
               <a:defRPr sz="1300" b="0">
                 <a:solidFill>
@@ -10546,13 +10546,13 @@
           <a:p>
             <a:pPr algn="l">
               <a:lnSpc>
-                <a:spcPts val="1600"/>
-              </a:lnSpc>
-              <a:spcBef>
-                <a:spcPts val="0"/>
-              </a:spcBef>
-              <a:spcAft>
-                <a:spcPts val="400"/>
+                <a:spcPct val="100000"/>
+              </a:lnSpc>
+              <a:spcBef>
+                <a:spcPts val="0"/>
+              </a:spcBef>
+              <a:spcAft>
+                <a:spcPts val="300"/>
               </a:spcAft>
               <a:defRPr sz="1300" b="0">
                 <a:solidFill>
@@ -10591,7 +10591,7 @@
           <a:p>
             <a:pPr algn="ctr">
               <a:lnSpc>
-                <a:spcPts val="1600"/>
+                <a:spcPct val="100000"/>
               </a:lnSpc>
               <a:spcBef>
                 <a:spcPts val="0"/>
@@ -10705,7 +10705,7 @@
           <a:p>
             <a:pPr algn="l">
               <a:lnSpc>
-                <a:spcPts val="1600"/>
+                <a:spcPct val="100000"/>
               </a:lnSpc>
               <a:spcBef>
                 <a:spcPts val="0"/>
@@ -10734,8 +10734,8 @@
         </p:nvSpPr>
         <p:spPr>
           <a:xfrm>
-            <a:off x="731520" y="1005840"/>
-            <a:ext cx="10058400" cy="640080"/>
+            <a:off x="731520" y="914400"/>
+            <a:ext cx="10515600" cy="914400"/>
           </a:xfrm>
           <a:prstGeom prst="rect">
             <a:avLst/>
@@ -10750,15 +10750,15 @@
           <a:p>
             <a:pPr algn="l">
               <a:lnSpc>
-                <a:spcPts val="4700"/>
-              </a:lnSpc>
-              <a:spcBef>
-                <a:spcPts val="0"/>
-              </a:spcBef>
-              <a:spcAft>
-                <a:spcPts val="0"/>
-              </a:spcAft>
-              <a:defRPr sz="3800" b="1">
+                <a:spcPct val="100000"/>
+              </a:lnSpc>
+              <a:spcBef>
+                <a:spcPts val="0"/>
+              </a:spcBef>
+              <a:spcAft>
+                <a:spcPts val="0"/>
+              </a:spcAft>
+              <a:defRPr sz="3400" b="1">
                 <a:solidFill>
                   <a:srgbClr val="1E2A38"/>
                 </a:solidFill>
@@ -10838,7 +10838,7 @@
           <a:p>
             <a:pPr algn="ctr">
               <a:lnSpc>
-                <a:spcPts val="6500"/>
+                <a:spcPct val="100000"/>
               </a:lnSpc>
               <a:spcBef>
                 <a:spcPts val="0"/>
@@ -10867,8 +10867,8 @@
         </p:nvSpPr>
         <p:spPr>
           <a:xfrm>
-            <a:off x="914400" y="3337560"/>
-            <a:ext cx="3108960" cy="457200"/>
+            <a:off x="914400" y="3291840"/>
+            <a:ext cx="3108960" cy="640080"/>
           </a:xfrm>
           <a:prstGeom prst="rect">
             <a:avLst/>
@@ -10883,15 +10883,15 @@
           <a:p>
             <a:pPr algn="ctr">
               <a:lnSpc>
-                <a:spcPts val="1800"/>
-              </a:lnSpc>
-              <a:spcBef>
-                <a:spcPts val="0"/>
-              </a:spcBef>
-              <a:spcAft>
-                <a:spcPts val="0"/>
-              </a:spcAft>
-              <a:defRPr sz="1500" b="0">
+                <a:spcPct val="100000"/>
+              </a:lnSpc>
+              <a:spcBef>
+                <a:spcPts val="0"/>
+              </a:spcBef>
+              <a:spcAft>
+                <a:spcPts val="0"/>
+              </a:spcAft>
+              <a:defRPr sz="1400" b="0">
                 <a:solidFill>
                   <a:srgbClr val="6B7280"/>
                 </a:solidFill>
@@ -10971,7 +10971,7 @@
           <a:p>
             <a:pPr algn="ctr">
               <a:lnSpc>
-                <a:spcPts val="6500"/>
+                <a:spcPct val="100000"/>
               </a:lnSpc>
               <a:spcBef>
                 <a:spcPts val="0"/>
@@ -11000,8 +11000,8 @@
         </p:nvSpPr>
         <p:spPr>
           <a:xfrm>
-            <a:off x="4480560" y="3337560"/>
-            <a:ext cx="3108960" cy="457200"/>
+            <a:off x="4480560" y="3291840"/>
+            <a:ext cx="3108960" cy="640080"/>
           </a:xfrm>
           <a:prstGeom prst="rect">
             <a:avLst/>
@@ -11016,15 +11016,15 @@
           <a:p>
             <a:pPr algn="ctr">
               <a:lnSpc>
-                <a:spcPts val="1800"/>
-              </a:lnSpc>
-              <a:spcBef>
-                <a:spcPts val="0"/>
-              </a:spcBef>
-              <a:spcAft>
-                <a:spcPts val="0"/>
-              </a:spcAft>
-              <a:defRPr sz="1500" b="0">
+                <a:spcPct val="100000"/>
+              </a:lnSpc>
+              <a:spcBef>
+                <a:spcPts val="0"/>
+              </a:spcBef>
+              <a:spcAft>
+                <a:spcPts val="0"/>
+              </a:spcAft>
+              <a:defRPr sz="1400" b="0">
                 <a:solidFill>
                   <a:srgbClr val="6B7280"/>
                 </a:solidFill>
@@ -11104,7 +11104,7 @@
           <a:p>
             <a:pPr algn="ctr">
               <a:lnSpc>
-                <a:spcPts val="6500"/>
+                <a:spcPct val="100000"/>
               </a:lnSpc>
               <a:spcBef>
                 <a:spcPts val="0"/>
@@ -11133,8 +11133,8 @@
         </p:nvSpPr>
         <p:spPr>
           <a:xfrm>
-            <a:off x="8046720" y="3337560"/>
-            <a:ext cx="3108960" cy="457200"/>
+            <a:off x="8046720" y="3291840"/>
+            <a:ext cx="3108960" cy="640080"/>
           </a:xfrm>
           <a:prstGeom prst="rect">
             <a:avLst/>
@@ -11149,15 +11149,15 @@
           <a:p>
             <a:pPr algn="ctr">
               <a:lnSpc>
-                <a:spcPts val="1800"/>
-              </a:lnSpc>
-              <a:spcBef>
-                <a:spcPts val="0"/>
-              </a:spcBef>
-              <a:spcAft>
-                <a:spcPts val="0"/>
-              </a:spcAft>
-              <a:defRPr sz="1500" b="0">
+                <a:spcPct val="100000"/>
+              </a:lnSpc>
+              <a:spcBef>
+                <a:spcPts val="0"/>
+              </a:spcBef>
+              <a:spcAft>
+                <a:spcPts val="0"/>
+              </a:spcAft>
+              <a:defRPr sz="1400" b="0">
                 <a:solidFill>
                   <a:srgbClr val="6B7280"/>
                 </a:solidFill>
@@ -11237,7 +11237,7 @@
           <a:p>
             <a:pPr algn="ctr">
               <a:lnSpc>
-                <a:spcPts val="6500"/>
+                <a:spcPct val="100000"/>
               </a:lnSpc>
               <a:spcBef>
                 <a:spcPts val="0"/>
@@ -11266,8 +11266,8 @@
         </p:nvSpPr>
         <p:spPr>
           <a:xfrm>
-            <a:off x="914400" y="5715000"/>
-            <a:ext cx="3108960" cy="457200"/>
+            <a:off x="914400" y="5669280"/>
+            <a:ext cx="3108960" cy="640080"/>
           </a:xfrm>
           <a:prstGeom prst="rect">
             <a:avLst/>
@@ -11282,15 +11282,15 @@
           <a:p>
             <a:pPr algn="ctr">
               <a:lnSpc>
-                <a:spcPts val="1800"/>
-              </a:lnSpc>
-              <a:spcBef>
-                <a:spcPts val="0"/>
-              </a:spcBef>
-              <a:spcAft>
-                <a:spcPts val="0"/>
-              </a:spcAft>
-              <a:defRPr sz="1500" b="0">
+                <a:spcPct val="100000"/>
+              </a:lnSpc>
+              <a:spcBef>
+                <a:spcPts val="0"/>
+              </a:spcBef>
+              <a:spcAft>
+                <a:spcPts val="0"/>
+              </a:spcAft>
+              <a:defRPr sz="1400" b="0">
                 <a:solidFill>
                   <a:srgbClr val="6B7280"/>
                 </a:solidFill>
@@ -11370,7 +11370,7 @@
           <a:p>
             <a:pPr algn="ctr">
               <a:lnSpc>
-                <a:spcPts val="6500"/>
+                <a:spcPct val="100000"/>
               </a:lnSpc>
               <a:spcBef>
                 <a:spcPts val="0"/>
@@ -11399,8 +11399,8 @@
         </p:nvSpPr>
         <p:spPr>
           <a:xfrm>
-            <a:off x="4480560" y="5715000"/>
-            <a:ext cx="3108960" cy="457200"/>
+            <a:off x="4480560" y="5669280"/>
+            <a:ext cx="3108960" cy="640080"/>
           </a:xfrm>
           <a:prstGeom prst="rect">
             <a:avLst/>
@@ -11415,15 +11415,15 @@
           <a:p>
             <a:pPr algn="ctr">
               <a:lnSpc>
-                <a:spcPts val="1800"/>
-              </a:lnSpc>
-              <a:spcBef>
-                <a:spcPts val="0"/>
-              </a:spcBef>
-              <a:spcAft>
-                <a:spcPts val="0"/>
-              </a:spcAft>
-              <a:defRPr sz="1500" b="0">
+                <a:spcPct val="100000"/>
+              </a:lnSpc>
+              <a:spcBef>
+                <a:spcPts val="0"/>
+              </a:spcBef>
+              <a:spcAft>
+                <a:spcPts val="0"/>
+              </a:spcAft>
+              <a:defRPr sz="1400" b="0">
                 <a:solidFill>
                   <a:srgbClr val="6B7280"/>
                 </a:solidFill>
@@ -11503,7 +11503,7 @@
           <a:p>
             <a:pPr algn="ctr">
               <a:lnSpc>
-                <a:spcPts val="6500"/>
+                <a:spcPct val="100000"/>
               </a:lnSpc>
               <a:spcBef>
                 <a:spcPts val="0"/>
@@ -11532,8 +11532,8 @@
         </p:nvSpPr>
         <p:spPr>
           <a:xfrm>
-            <a:off x="8046720" y="5715000"/>
-            <a:ext cx="3108960" cy="457200"/>
+            <a:off x="8046720" y="5669280"/>
+            <a:ext cx="3108960" cy="640080"/>
           </a:xfrm>
           <a:prstGeom prst="rect">
             <a:avLst/>
@@ -11548,15 +11548,15 @@
           <a:p>
             <a:pPr algn="ctr">
               <a:lnSpc>
-                <a:spcPts val="1800"/>
-              </a:lnSpc>
-              <a:spcBef>
-                <a:spcPts val="0"/>
-              </a:spcBef>
-              <a:spcAft>
-                <a:spcPts val="0"/>
-              </a:spcAft>
-              <a:defRPr sz="1500" b="0">
+                <a:spcPct val="100000"/>
+              </a:lnSpc>
+              <a:spcBef>
+                <a:spcPts val="0"/>
+              </a:spcBef>
+              <a:spcAft>
+                <a:spcPts val="0"/>
+              </a:spcAft>
+              <a:defRPr sz="1400" b="0">
                 <a:solidFill>
                   <a:srgbClr val="6B7280"/>
                 </a:solidFill>
@@ -11662,7 +11662,7 @@
           <a:p>
             <a:pPr algn="l">
               <a:lnSpc>
-                <a:spcPts val="1600"/>
+                <a:spcPct val="100000"/>
               </a:lnSpc>
               <a:spcBef>
                 <a:spcPts val="0"/>
@@ -11691,8 +11691,8 @@
         </p:nvSpPr>
         <p:spPr>
           <a:xfrm>
-            <a:off x="731520" y="1005840"/>
-            <a:ext cx="10058400" cy="640080"/>
+            <a:off x="731520" y="914400"/>
+            <a:ext cx="10515600" cy="914400"/>
           </a:xfrm>
           <a:prstGeom prst="rect">
             <a:avLst/>
@@ -11707,15 +11707,15 @@
           <a:p>
             <a:pPr algn="l">
               <a:lnSpc>
-                <a:spcPts val="4700"/>
-              </a:lnSpc>
-              <a:spcBef>
-                <a:spcPts val="0"/>
-              </a:spcBef>
-              <a:spcAft>
-                <a:spcPts val="0"/>
-              </a:spcAft>
-              <a:defRPr sz="3800" b="1">
+                <a:spcPct val="100000"/>
+              </a:lnSpc>
+              <a:spcBef>
+                <a:spcPts val="0"/>
+              </a:spcBef>
+              <a:spcAft>
+                <a:spcPts val="0"/>
+              </a:spcAft>
+              <a:defRPr sz="3400" b="1">
                 <a:solidFill>
                   <a:srgbClr val="1E2A38"/>
                 </a:solidFill>
@@ -11736,7 +11736,7 @@
         </p:nvSpPr>
         <p:spPr>
           <a:xfrm>
-            <a:off x="914400" y="2121408"/>
+            <a:off x="914400" y="2212848"/>
             <a:ext cx="164592" cy="164592"/>
           </a:xfrm>
           <a:prstGeom prst="ellipse">
@@ -11779,8 +11779,8 @@
         </p:nvSpPr>
         <p:spPr>
           <a:xfrm>
-            <a:off x="1371600" y="2011680"/>
-            <a:ext cx="3657600" cy="365760"/>
+            <a:off x="1371600" y="2103120"/>
+            <a:ext cx="3657600" cy="548640"/>
           </a:xfrm>
           <a:prstGeom prst="rect">
             <a:avLst/>
@@ -11795,15 +11795,15 @@
           <a:p>
             <a:pPr algn="l">
               <a:lnSpc>
-                <a:spcPts val="2000"/>
-              </a:lnSpc>
-              <a:spcBef>
-                <a:spcPts val="0"/>
-              </a:spcBef>
-              <a:spcAft>
-                <a:spcPts val="0"/>
-              </a:spcAft>
-              <a:defRPr sz="1600" b="1">
+                <a:spcPct val="100000"/>
+              </a:lnSpc>
+              <a:spcBef>
+                <a:spcPts val="0"/>
+              </a:spcBef>
+              <a:spcAft>
+                <a:spcPts val="0"/>
+              </a:spcAft>
+              <a:defRPr sz="1400" b="1">
                 <a:solidFill>
                   <a:srgbClr val="1E2A38"/>
                 </a:solidFill>
@@ -11824,8 +11824,8 @@
         </p:nvSpPr>
         <p:spPr>
           <a:xfrm>
-            <a:off x="5029200" y="2011680"/>
-            <a:ext cx="6400800" cy="731520"/>
+            <a:off x="5212080" y="2103120"/>
+            <a:ext cx="6217920" cy="731520"/>
           </a:xfrm>
           <a:prstGeom prst="rect">
             <a:avLst/>
@@ -11840,15 +11840,15 @@
           <a:p>
             <a:pPr algn="l">
               <a:lnSpc>
-                <a:spcPts val="1700"/>
-              </a:lnSpc>
-              <a:spcBef>
-                <a:spcPts val="0"/>
-              </a:spcBef>
-              <a:spcAft>
-                <a:spcPts val="0"/>
-              </a:spcAft>
-              <a:defRPr sz="1400" b="0">
+                <a:spcPct val="100000"/>
+              </a:lnSpc>
+              <a:spcBef>
+                <a:spcPts val="0"/>
+              </a:spcBef>
+              <a:spcAft>
+                <a:spcPts val="0"/>
+              </a:spcAft>
+              <a:defRPr sz="1300" b="0">
                 <a:solidFill>
                   <a:srgbClr val="6B7280"/>
                 </a:solidFill>
@@ -11869,7 +11869,7 @@
         </p:nvSpPr>
         <p:spPr>
           <a:xfrm>
-            <a:off x="914400" y="3035808"/>
+            <a:off x="914400" y="3127248"/>
             <a:ext cx="164592" cy="164592"/>
           </a:xfrm>
           <a:prstGeom prst="ellipse">
@@ -11912,8 +11912,8 @@
         </p:nvSpPr>
         <p:spPr>
           <a:xfrm>
-            <a:off x="1371600" y="2926080"/>
-            <a:ext cx="3657600" cy="365760"/>
+            <a:off x="1371600" y="3017520"/>
+            <a:ext cx="3657600" cy="548640"/>
           </a:xfrm>
           <a:prstGeom prst="rect">
             <a:avLst/>
@@ -11928,15 +11928,15 @@
           <a:p>
             <a:pPr algn="l">
               <a:lnSpc>
-                <a:spcPts val="2000"/>
-              </a:lnSpc>
-              <a:spcBef>
-                <a:spcPts val="0"/>
-              </a:spcBef>
-              <a:spcAft>
-                <a:spcPts val="0"/>
-              </a:spcAft>
-              <a:defRPr sz="1600" b="1">
+                <a:spcPct val="100000"/>
+              </a:lnSpc>
+              <a:spcBef>
+                <a:spcPts val="0"/>
+              </a:spcBef>
+              <a:spcAft>
+                <a:spcPts val="0"/>
+              </a:spcAft>
+              <a:defRPr sz="1400" b="1">
                 <a:solidFill>
                   <a:srgbClr val="1E2A38"/>
                 </a:solidFill>
@@ -11957,8 +11957,8 @@
         </p:nvSpPr>
         <p:spPr>
           <a:xfrm>
-            <a:off x="5029200" y="2926080"/>
-            <a:ext cx="6400800" cy="731520"/>
+            <a:off x="5212080" y="3017520"/>
+            <a:ext cx="6217920" cy="731520"/>
           </a:xfrm>
           <a:prstGeom prst="rect">
             <a:avLst/>
@@ -11973,15 +11973,15 @@
           <a:p>
             <a:pPr algn="l">
               <a:lnSpc>
-                <a:spcPts val="1700"/>
-              </a:lnSpc>
-              <a:spcBef>
-                <a:spcPts val="0"/>
-              </a:spcBef>
-              <a:spcAft>
-                <a:spcPts val="0"/>
-              </a:spcAft>
-              <a:defRPr sz="1400" b="0">
+                <a:spcPct val="100000"/>
+              </a:lnSpc>
+              <a:spcBef>
+                <a:spcPts val="0"/>
+              </a:spcBef>
+              <a:spcAft>
+                <a:spcPts val="0"/>
+              </a:spcAft>
+              <a:defRPr sz="1300" b="0">
                 <a:solidFill>
                   <a:srgbClr val="6B7280"/>
                 </a:solidFill>
@@ -12002,7 +12002,7 @@
         </p:nvSpPr>
         <p:spPr>
           <a:xfrm>
-            <a:off x="914400" y="3950208"/>
+            <a:off x="914400" y="4041648"/>
             <a:ext cx="164592" cy="164592"/>
           </a:xfrm>
           <a:prstGeom prst="ellipse">
@@ -12045,8 +12045,8 @@
         </p:nvSpPr>
         <p:spPr>
           <a:xfrm>
-            <a:off x="1371600" y="3840480"/>
-            <a:ext cx="3657600" cy="365760"/>
+            <a:off x="1371600" y="3931920"/>
+            <a:ext cx="3657600" cy="548640"/>
           </a:xfrm>
           <a:prstGeom prst="rect">
             <a:avLst/>
@@ -12061,15 +12061,15 @@
           <a:p>
             <a:pPr algn="l">
               <a:lnSpc>
-                <a:spcPts val="2000"/>
-              </a:lnSpc>
-              <a:spcBef>
-                <a:spcPts val="0"/>
-              </a:spcBef>
-              <a:spcAft>
-                <a:spcPts val="0"/>
-              </a:spcAft>
-              <a:defRPr sz="1600" b="1">
+                <a:spcPct val="100000"/>
+              </a:lnSpc>
+              <a:spcBef>
+                <a:spcPts val="0"/>
+              </a:spcBef>
+              <a:spcAft>
+                <a:spcPts val="0"/>
+              </a:spcAft>
+              <a:defRPr sz="1400" b="1">
                 <a:solidFill>
                   <a:srgbClr val="1E2A38"/>
                 </a:solidFill>
@@ -12090,8 +12090,8 @@
         </p:nvSpPr>
         <p:spPr>
           <a:xfrm>
-            <a:off x="5029200" y="3840480"/>
-            <a:ext cx="6400800" cy="731520"/>
+            <a:off x="5212080" y="3931920"/>
+            <a:ext cx="6217920" cy="731520"/>
           </a:xfrm>
           <a:prstGeom prst="rect">
             <a:avLst/>
@@ -12106,15 +12106,15 @@
           <a:p>
             <a:pPr algn="l">
               <a:lnSpc>
-                <a:spcPts val="1700"/>
-              </a:lnSpc>
-              <a:spcBef>
-                <a:spcPts val="0"/>
-              </a:spcBef>
-              <a:spcAft>
-                <a:spcPts val="0"/>
-              </a:spcAft>
-              <a:defRPr sz="1400" b="0">
+                <a:spcPct val="100000"/>
+              </a:lnSpc>
+              <a:spcBef>
+                <a:spcPts val="0"/>
+              </a:spcBef>
+              <a:spcAft>
+                <a:spcPts val="0"/>
+              </a:spcAft>
+              <a:defRPr sz="1300" b="0">
                 <a:solidFill>
                   <a:srgbClr val="6B7280"/>
                 </a:solidFill>
@@ -12135,7 +12135,7 @@
         </p:nvSpPr>
         <p:spPr>
           <a:xfrm>
-            <a:off x="914400" y="4864608"/>
+            <a:off x="914400" y="4956048"/>
             <a:ext cx="164592" cy="164592"/>
           </a:xfrm>
           <a:prstGeom prst="ellipse">
@@ -12178,8 +12178,8 @@
         </p:nvSpPr>
         <p:spPr>
           <a:xfrm>
-            <a:off x="1371600" y="4754880"/>
-            <a:ext cx="3657600" cy="365760"/>
+            <a:off x="1371600" y="4846320"/>
+            <a:ext cx="3657600" cy="548640"/>
           </a:xfrm>
           <a:prstGeom prst="rect">
             <a:avLst/>
@@ -12194,15 +12194,15 @@
           <a:p>
             <a:pPr algn="l">
               <a:lnSpc>
-                <a:spcPts val="2000"/>
-              </a:lnSpc>
-              <a:spcBef>
-                <a:spcPts val="0"/>
-              </a:spcBef>
-              <a:spcAft>
-                <a:spcPts val="0"/>
-              </a:spcAft>
-              <a:defRPr sz="1600" b="1">
+                <a:spcPct val="100000"/>
+              </a:lnSpc>
+              <a:spcBef>
+                <a:spcPts val="0"/>
+              </a:spcBef>
+              <a:spcAft>
+                <a:spcPts val="0"/>
+              </a:spcAft>
+              <a:defRPr sz="1400" b="1">
                 <a:solidFill>
                   <a:srgbClr val="1E2A38"/>
                 </a:solidFill>
@@ -12223,8 +12223,8 @@
         </p:nvSpPr>
         <p:spPr>
           <a:xfrm>
-            <a:off x="5029200" y="4754880"/>
-            <a:ext cx="6400800" cy="731520"/>
+            <a:off x="5212080" y="4846320"/>
+            <a:ext cx="6217920" cy="731520"/>
           </a:xfrm>
           <a:prstGeom prst="rect">
             <a:avLst/>
@@ -12239,15 +12239,15 @@
           <a:p>
             <a:pPr algn="l">
               <a:lnSpc>
-                <a:spcPts val="1700"/>
-              </a:lnSpc>
-              <a:spcBef>
-                <a:spcPts val="0"/>
-              </a:spcBef>
-              <a:spcAft>
-                <a:spcPts val="0"/>
-              </a:spcAft>
-              <a:defRPr sz="1400" b="0">
+                <a:spcPct val="100000"/>
+              </a:lnSpc>
+              <a:spcBef>
+                <a:spcPts val="0"/>
+              </a:spcBef>
+              <a:spcAft>
+                <a:spcPts val="0"/>
+              </a:spcAft>
+              <a:defRPr sz="1300" b="0">
                 <a:solidFill>
                   <a:srgbClr val="6B7280"/>
                 </a:solidFill>
@@ -12268,7 +12268,7 @@
         </p:nvSpPr>
         <p:spPr>
           <a:xfrm>
-            <a:off x="914400" y="5779008"/>
+            <a:off x="914400" y="5870448"/>
             <a:ext cx="164592" cy="164592"/>
           </a:xfrm>
           <a:prstGeom prst="ellipse">
@@ -12311,8 +12311,8 @@
         </p:nvSpPr>
         <p:spPr>
           <a:xfrm>
-            <a:off x="1371600" y="5669280"/>
-            <a:ext cx="3657600" cy="365760"/>
+            <a:off x="1371600" y="5760720"/>
+            <a:ext cx="3657600" cy="548640"/>
           </a:xfrm>
           <a:prstGeom prst="rect">
             <a:avLst/>
@@ -12327,15 +12327,15 @@
           <a:p>
             <a:pPr algn="l">
               <a:lnSpc>
-                <a:spcPts val="2000"/>
-              </a:lnSpc>
-              <a:spcBef>
-                <a:spcPts val="0"/>
-              </a:spcBef>
-              <a:spcAft>
-                <a:spcPts val="0"/>
-              </a:spcAft>
-              <a:defRPr sz="1600" b="1">
+                <a:spcPct val="100000"/>
+              </a:lnSpc>
+              <a:spcBef>
+                <a:spcPts val="0"/>
+              </a:spcBef>
+              <a:spcAft>
+                <a:spcPts val="0"/>
+              </a:spcAft>
+              <a:defRPr sz="1400" b="1">
                 <a:solidFill>
                   <a:srgbClr val="1E2A38"/>
                 </a:solidFill>
@@ -12343,7 +12343,7 @@
               </a:defRPr>
             </a:pPr>
             <a:r>
-              <a:t>Alumni network + cold email outreach</a:t>
+              <a:t>Alumni + cold email outreach</a:t>
             </a:r>
           </a:p>
         </p:txBody>
@@ -12356,8 +12356,8 @@
         </p:nvSpPr>
         <p:spPr>
           <a:xfrm>
-            <a:off x="5029200" y="5669280"/>
-            <a:ext cx="6400800" cy="731520"/>
+            <a:off x="5212080" y="5760720"/>
+            <a:ext cx="6217920" cy="731520"/>
           </a:xfrm>
           <a:prstGeom prst="rect">
             <a:avLst/>
@@ -12372,15 +12372,15 @@
           <a:p>
             <a:pPr algn="l">
               <a:lnSpc>
-                <a:spcPts val="1700"/>
-              </a:lnSpc>
-              <a:spcBef>
-                <a:spcPts val="0"/>
-              </a:spcBef>
-              <a:spcAft>
-                <a:spcPts val="0"/>
-              </a:spcAft>
-              <a:defRPr sz="1400" b="0">
+                <a:spcPct val="100000"/>
+              </a:lnSpc>
+              <a:spcBef>
+                <a:spcPts val="0"/>
+              </a:spcBef>
+              <a:spcAft>
+                <a:spcPts val="0"/>
+              </a:spcAft>
+              <a:defRPr sz="1300" b="0">
                 <a:solidFill>
                   <a:srgbClr val="6B7280"/>
                 </a:solidFill>
@@ -12486,7 +12486,7 @@
           <a:p>
             <a:pPr algn="l">
               <a:lnSpc>
-                <a:spcPts val="1600"/>
+                <a:spcPct val="100000"/>
               </a:lnSpc>
               <a:spcBef>
                 <a:spcPts val="0"/>
@@ -12515,8 +12515,8 @@
         </p:nvSpPr>
         <p:spPr>
           <a:xfrm>
-            <a:off x="731520" y="914400"/>
-            <a:ext cx="10058400" cy="640080"/>
+            <a:off x="731520" y="822960"/>
+            <a:ext cx="10515600" cy="914400"/>
           </a:xfrm>
           <a:prstGeom prst="rect">
             <a:avLst/>
@@ -12531,15 +12531,15 @@
           <a:p>
             <a:pPr algn="l">
               <a:lnSpc>
-                <a:spcPts val="4500"/>
-              </a:lnSpc>
-              <a:spcBef>
-                <a:spcPts val="0"/>
-              </a:spcBef>
-              <a:spcAft>
-                <a:spcPts val="0"/>
-              </a:spcAft>
-              <a:defRPr sz="3600" b="1">
+                <a:spcPct val="100000"/>
+              </a:lnSpc>
+              <a:spcBef>
+                <a:spcPts val="0"/>
+              </a:spcBef>
+              <a:spcAft>
+                <a:spcPts val="0"/>
+              </a:spcAft>
+              <a:defRPr sz="3200" b="1">
                 <a:solidFill>
                   <a:srgbClr val="FFFFFF"/>
                 </a:solidFill>
@@ -12662,7 +12662,7 @@
           <a:p>
             <a:pPr algn="ctr">
               <a:lnSpc>
-                <a:spcPts val="3200"/>
+                <a:spcPct val="100000"/>
               </a:lnSpc>
               <a:spcBef>
                 <a:spcPts val="0"/>
@@ -12692,7 +12692,7 @@
         <p:spPr>
           <a:xfrm>
             <a:off x="594360" y="3246120"/>
-            <a:ext cx="1828800" cy="411480"/>
+            <a:ext cx="1828800" cy="502920"/>
           </a:xfrm>
           <a:prstGeom prst="rect">
             <a:avLst/>
@@ -12707,15 +12707,15 @@
           <a:p>
             <a:pPr algn="ctr">
               <a:lnSpc>
-                <a:spcPts val="2100"/>
-              </a:lnSpc>
-              <a:spcBef>
-                <a:spcPts val="0"/>
-              </a:spcBef>
-              <a:spcAft>
-                <a:spcPts val="0"/>
-              </a:spcAft>
-              <a:defRPr sz="1700" b="1">
+                <a:spcPct val="100000"/>
+              </a:lnSpc>
+              <a:spcBef>
+                <a:spcPts val="0"/>
+              </a:spcBef>
+              <a:spcAft>
+                <a:spcPts val="0"/>
+              </a:spcAft>
+              <a:defRPr sz="1500" b="1">
                 <a:solidFill>
                   <a:srgbClr val="FFFFFF"/>
                 </a:solidFill>
@@ -12752,13 +12752,13 @@
           <a:p>
             <a:pPr algn="ctr">
               <a:lnSpc>
-                <a:spcPts val="1600"/>
-              </a:lnSpc>
-              <a:spcBef>
-                <a:spcPts val="0"/>
-              </a:spcBef>
-              <a:spcAft>
-                <a:spcPts val="400"/>
+                <a:spcPct val="100000"/>
+              </a:lnSpc>
+              <a:spcBef>
+                <a:spcPts val="0"/>
+              </a:spcBef>
+              <a:spcAft>
+                <a:spcPts val="300"/>
               </a:spcAft>
               <a:defRPr sz="1300" b="0">
                 <a:solidFill>
@@ -12774,13 +12774,13 @@
           <a:p>
             <a:pPr algn="ctr">
               <a:lnSpc>
-                <a:spcPts val="1600"/>
-              </a:lnSpc>
-              <a:spcBef>
-                <a:spcPts val="0"/>
-              </a:spcBef>
-              <a:spcAft>
-                <a:spcPts val="400"/>
+                <a:spcPct val="100000"/>
+              </a:lnSpc>
+              <a:spcBef>
+                <a:spcPts val="0"/>
+              </a:spcBef>
+              <a:spcAft>
+                <a:spcPts val="300"/>
               </a:spcAft>
               <a:defRPr sz="1300" b="0">
                 <a:solidFill>
@@ -12819,7 +12819,7 @@
           <a:p>
             <a:pPr algn="ctr">
               <a:lnSpc>
-                <a:spcPts val="2200"/>
+                <a:spcPct val="100000"/>
               </a:lnSpc>
               <a:spcBef>
                 <a:spcPts val="0"/>
@@ -12950,7 +12950,7 @@
           <a:p>
             <a:pPr algn="ctr">
               <a:lnSpc>
-                <a:spcPts val="3200"/>
+                <a:spcPct val="100000"/>
               </a:lnSpc>
               <a:spcBef>
                 <a:spcPts val="0"/>
@@ -12980,7 +12980,7 @@
         <p:spPr>
           <a:xfrm>
             <a:off x="2926080" y="3246120"/>
-            <a:ext cx="1828800" cy="411480"/>
+            <a:ext cx="1828800" cy="502920"/>
           </a:xfrm>
           <a:prstGeom prst="rect">
             <a:avLst/>
@@ -12995,15 +12995,15 @@
           <a:p>
             <a:pPr algn="ctr">
               <a:lnSpc>
-                <a:spcPts val="2100"/>
-              </a:lnSpc>
-              <a:spcBef>
-                <a:spcPts val="0"/>
-              </a:spcBef>
-              <a:spcAft>
-                <a:spcPts val="0"/>
-              </a:spcAft>
-              <a:defRPr sz="1700" b="1">
+                <a:spcPct val="100000"/>
+              </a:lnSpc>
+              <a:spcBef>
+                <a:spcPts val="0"/>
+              </a:spcBef>
+              <a:spcAft>
+                <a:spcPts val="0"/>
+              </a:spcAft>
+              <a:defRPr sz="1500" b="1">
                 <a:solidFill>
                   <a:srgbClr val="FFFFFF"/>
                 </a:solidFill>
@@ -13040,13 +13040,13 @@
           <a:p>
             <a:pPr algn="ctr">
               <a:lnSpc>
-                <a:spcPts val="1600"/>
-              </a:lnSpc>
-              <a:spcBef>
-                <a:spcPts val="0"/>
-              </a:spcBef>
-              <a:spcAft>
-                <a:spcPts val="400"/>
+                <a:spcPct val="100000"/>
+              </a:lnSpc>
+              <a:spcBef>
+                <a:spcPts val="0"/>
+              </a:spcBef>
+              <a:spcAft>
+                <a:spcPts val="300"/>
               </a:spcAft>
               <a:defRPr sz="1300" b="0">
                 <a:solidFill>
@@ -13062,13 +13062,13 @@
           <a:p>
             <a:pPr algn="ctr">
               <a:lnSpc>
-                <a:spcPts val="1600"/>
-              </a:lnSpc>
-              <a:spcBef>
-                <a:spcPts val="0"/>
-              </a:spcBef>
-              <a:spcAft>
-                <a:spcPts val="400"/>
+                <a:spcPct val="100000"/>
+              </a:lnSpc>
+              <a:spcBef>
+                <a:spcPts val="0"/>
+              </a:spcBef>
+              <a:spcAft>
+                <a:spcPts val="300"/>
               </a:spcAft>
               <a:defRPr sz="1300" b="0">
                 <a:solidFill>
@@ -13107,7 +13107,7 @@
           <a:p>
             <a:pPr algn="ctr">
               <a:lnSpc>
-                <a:spcPts val="2200"/>
+                <a:spcPct val="100000"/>
               </a:lnSpc>
               <a:spcBef>
                 <a:spcPts val="0"/>
@@ -13238,7 +13238,7 @@
           <a:p>
             <a:pPr algn="ctr">
               <a:lnSpc>
-                <a:spcPts val="3200"/>
+                <a:spcPct val="100000"/>
               </a:lnSpc>
               <a:spcBef>
                 <a:spcPts val="0"/>
@@ -13268,7 +13268,7 @@
         <p:spPr>
           <a:xfrm>
             <a:off x="5257800" y="3246120"/>
-            <a:ext cx="1828800" cy="411480"/>
+            <a:ext cx="1828800" cy="502920"/>
           </a:xfrm>
           <a:prstGeom prst="rect">
             <a:avLst/>
@@ -13283,15 +13283,15 @@
           <a:p>
             <a:pPr algn="ctr">
               <a:lnSpc>
-                <a:spcPts val="2100"/>
-              </a:lnSpc>
-              <a:spcBef>
-                <a:spcPts val="0"/>
-              </a:spcBef>
-              <a:spcAft>
-                <a:spcPts val="0"/>
-              </a:spcAft>
-              <a:defRPr sz="1700" b="1">
+                <a:spcPct val="100000"/>
+              </a:lnSpc>
+              <a:spcBef>
+                <a:spcPts val="0"/>
+              </a:spcBef>
+              <a:spcAft>
+                <a:spcPts val="0"/>
+              </a:spcAft>
+              <a:defRPr sz="1500" b="1">
                 <a:solidFill>
                   <a:srgbClr val="FFFFFF"/>
                 </a:solidFill>
@@ -13328,13 +13328,13 @@
           <a:p>
             <a:pPr algn="ctr">
               <a:lnSpc>
-                <a:spcPts val="1600"/>
-              </a:lnSpc>
-              <a:spcBef>
-                <a:spcPts val="0"/>
-              </a:spcBef>
-              <a:spcAft>
-                <a:spcPts val="400"/>
+                <a:spcPct val="100000"/>
+              </a:lnSpc>
+              <a:spcBef>
+                <a:spcPts val="0"/>
+              </a:spcBef>
+              <a:spcAft>
+                <a:spcPts val="300"/>
               </a:spcAft>
               <a:defRPr sz="1300" b="0">
                 <a:solidFill>
@@ -13350,13 +13350,13 @@
           <a:p>
             <a:pPr algn="ctr">
               <a:lnSpc>
-                <a:spcPts val="1600"/>
-              </a:lnSpc>
-              <a:spcBef>
-                <a:spcPts val="0"/>
-              </a:spcBef>
-              <a:spcAft>
-                <a:spcPts val="400"/>
+                <a:spcPct val="100000"/>
+              </a:lnSpc>
+              <a:spcBef>
+                <a:spcPts val="0"/>
+              </a:spcBef>
+              <a:spcAft>
+                <a:spcPts val="300"/>
               </a:spcAft>
               <a:defRPr sz="1300" b="0">
                 <a:solidFill>
@@ -13395,7 +13395,7 @@
           <a:p>
             <a:pPr algn="ctr">
               <a:lnSpc>
-                <a:spcPts val="2200"/>
+                <a:spcPct val="100000"/>
               </a:lnSpc>
               <a:spcBef>
                 <a:spcPts val="0"/>
@@ -13526,7 +13526,7 @@
           <a:p>
             <a:pPr algn="ctr">
               <a:lnSpc>
-                <a:spcPts val="3200"/>
+                <a:spcPct val="100000"/>
               </a:lnSpc>
               <a:spcBef>
                 <a:spcPts val="0"/>
@@ -13556,7 +13556,7 @@
         <p:spPr>
           <a:xfrm>
             <a:off x="7589520" y="3246120"/>
-            <a:ext cx="1828800" cy="411480"/>
+            <a:ext cx="1828800" cy="502920"/>
           </a:xfrm>
           <a:prstGeom prst="rect">
             <a:avLst/>
@@ -13571,15 +13571,15 @@
           <a:p>
             <a:pPr algn="ctr">
               <a:lnSpc>
-                <a:spcPts val="2100"/>
-              </a:lnSpc>
-              <a:spcBef>
-                <a:spcPts val="0"/>
-              </a:spcBef>
-              <a:spcAft>
-                <a:spcPts val="0"/>
-              </a:spcAft>
-              <a:defRPr sz="1700" b="1">
+                <a:spcPct val="100000"/>
+              </a:lnSpc>
+              <a:spcBef>
+                <a:spcPts val="0"/>
+              </a:spcBef>
+              <a:spcAft>
+                <a:spcPts val="0"/>
+              </a:spcAft>
+              <a:defRPr sz="1500" b="1">
                 <a:solidFill>
                   <a:srgbClr val="FFFFFF"/>
                 </a:solidFill>
@@ -13616,13 +13616,13 @@
           <a:p>
             <a:pPr algn="ctr">
               <a:lnSpc>
-                <a:spcPts val="1600"/>
-              </a:lnSpc>
-              <a:spcBef>
-                <a:spcPts val="0"/>
-              </a:spcBef>
-              <a:spcAft>
-                <a:spcPts val="400"/>
+                <a:spcPct val="100000"/>
+              </a:lnSpc>
+              <a:spcBef>
+                <a:spcPts val="0"/>
+              </a:spcBef>
+              <a:spcAft>
+                <a:spcPts val="300"/>
               </a:spcAft>
               <a:defRPr sz="1300" b="0">
                 <a:solidFill>
@@ -13638,13 +13638,13 @@
           <a:p>
             <a:pPr algn="ctr">
               <a:lnSpc>
-                <a:spcPts val="1600"/>
-              </a:lnSpc>
-              <a:spcBef>
-                <a:spcPts val="0"/>
-              </a:spcBef>
-              <a:spcAft>
-                <a:spcPts val="400"/>
+                <a:spcPct val="100000"/>
+              </a:lnSpc>
+              <a:spcBef>
+                <a:spcPts val="0"/>
+              </a:spcBef>
+              <a:spcAft>
+                <a:spcPts val="300"/>
               </a:spcAft>
               <a:defRPr sz="1300" b="0">
                 <a:solidFill>
@@ -13683,7 +13683,7 @@
           <a:p>
             <a:pPr algn="ctr">
               <a:lnSpc>
-                <a:spcPts val="2200"/>
+                <a:spcPct val="100000"/>
               </a:lnSpc>
               <a:spcBef>
                 <a:spcPts val="0"/>
@@ -13814,7 +13814,7 @@
           <a:p>
             <a:pPr algn="ctr">
               <a:lnSpc>
-                <a:spcPts val="3200"/>
+                <a:spcPct val="100000"/>
               </a:lnSpc>
               <a:spcBef>
                 <a:spcPts val="0"/>
@@ -13844,7 +13844,7 @@
         <p:spPr>
           <a:xfrm>
             <a:off x="9921240" y="3246120"/>
-            <a:ext cx="1828800" cy="411480"/>
+            <a:ext cx="1828800" cy="502920"/>
           </a:xfrm>
           <a:prstGeom prst="rect">
             <a:avLst/>
@@ -13859,15 +13859,15 @@
           <a:p>
             <a:pPr algn="ctr">
               <a:lnSpc>
-                <a:spcPts val="2100"/>
-              </a:lnSpc>
-              <a:spcBef>
-                <a:spcPts val="0"/>
-              </a:spcBef>
-              <a:spcAft>
-                <a:spcPts val="0"/>
-              </a:spcAft>
-              <a:defRPr sz="1700" b="1">
+                <a:spcPct val="100000"/>
+              </a:lnSpc>
+              <a:spcBef>
+                <a:spcPts val="0"/>
+              </a:spcBef>
+              <a:spcAft>
+                <a:spcPts val="0"/>
+              </a:spcAft>
+              <a:defRPr sz="1500" b="1">
                 <a:solidFill>
                   <a:srgbClr val="FFFFFF"/>
                 </a:solidFill>
@@ -13904,13 +13904,13 @@
           <a:p>
             <a:pPr algn="ctr">
               <a:lnSpc>
-                <a:spcPts val="1600"/>
-              </a:lnSpc>
-              <a:spcBef>
-                <a:spcPts val="0"/>
-              </a:spcBef>
-              <a:spcAft>
-                <a:spcPts val="400"/>
+                <a:spcPct val="100000"/>
+              </a:lnSpc>
+              <a:spcBef>
+                <a:spcPts val="0"/>
+              </a:spcBef>
+              <a:spcAft>
+                <a:spcPts val="300"/>
               </a:spcAft>
               <a:defRPr sz="1300" b="0">
                 <a:solidFill>
@@ -13926,13 +13926,13 @@
           <a:p>
             <a:pPr algn="ctr">
               <a:lnSpc>
-                <a:spcPts val="1600"/>
-              </a:lnSpc>
-              <a:spcBef>
-                <a:spcPts val="0"/>
-              </a:spcBef>
-              <a:spcAft>
-                <a:spcPts val="400"/>
+                <a:spcPct val="100000"/>
+              </a:lnSpc>
+              <a:spcBef>
+                <a:spcPts val="0"/>
+              </a:spcBef>
+              <a:spcAft>
+                <a:spcPts val="300"/>
               </a:spcAft>
               <a:defRPr sz="1300" b="0">
                 <a:solidFill>
@@ -13971,7 +13971,7 @@
           <a:p>
             <a:pPr algn="ctr">
               <a:lnSpc>
-                <a:spcPts val="1700"/>
+                <a:spcPct val="100000"/>
               </a:lnSpc>
               <a:spcBef>
                 <a:spcPts val="0"/>

</xml_diff>

<commit_message>
Replace MIS text with sparkle icon on closing slide
Matches the app's logo: Lucide Sparkles icon inside a Davidson-red
rounded rect, as seen in the dashboard sidebar.

https://claude.ai/code/session_01PtY49K7bv5r2r99EhAAhgg
</commit_message>
<xml_diff>
--- a/MakeItSo_Pitch_Deck.pptx
+++ b/MakeItSo_Pitch_Deck.pptx
@@ -4615,8 +4615,8 @@
         </p:nvSpPr>
         <p:spPr>
           <a:xfrm>
-            <a:off x="5394960" y="1325880"/>
-            <a:ext cx="1371600" cy="1097280"/>
+            <a:off x="5394960" y="1280160"/>
+            <a:ext cx="1371600" cy="1188720"/>
           </a:xfrm>
           <a:prstGeom prst="rect">
             <a:avLst/>
@@ -4639,15 +4639,15 @@
               <a:spcAft>
                 <a:spcPts val="0"/>
               </a:spcAft>
-              <a:defRPr sz="3600" b="1">
+              <a:defRPr sz="4800" b="0">
                 <a:solidFill>
                   <a:srgbClr val="FFFFFF"/>
                 </a:solidFill>
-                <a:latin typeface="Georgia"/>
-              </a:defRPr>
-            </a:pPr>
-            <a:r>
-              <a:t>MIS</a:t>
+                <a:latin typeface="Segoe UI Emoji"/>
+              </a:defRPr>
+            </a:pPr>
+            <a:r>
+              <a:t>✨</a:t>
             </a:r>
           </a:p>
         </p:txBody>

</xml_diff>

<commit_message>
Replace MIS text with sparkle icon on title slide too
https://claude.ai/code/session_01PtY49K7bv5r2r99EhAAhgg
</commit_message>
<xml_diff>
--- a/MakeItSo_Pitch_Deck.pptx
+++ b/MakeItSo_Pitch_Deck.pptx
@@ -3286,8 +3286,8 @@
         </p:nvSpPr>
         <p:spPr>
           <a:xfrm>
-            <a:off x="5394960" y="1600200"/>
-            <a:ext cx="1371600" cy="1097280"/>
+            <a:off x="5394960" y="1554480"/>
+            <a:ext cx="1371600" cy="1188720"/>
           </a:xfrm>
           <a:prstGeom prst="rect">
             <a:avLst/>
@@ -3310,15 +3310,15 @@
               <a:spcAft>
                 <a:spcPts val="0"/>
               </a:spcAft>
-              <a:defRPr sz="3600" b="1">
+              <a:defRPr sz="4800" b="0">
                 <a:solidFill>
                   <a:srgbClr val="FFFFFF"/>
                 </a:solidFill>
-                <a:latin typeface="Georgia"/>
-              </a:defRPr>
-            </a:pPr>
-            <a:r>
-              <a:t>MIS</a:t>
+                <a:latin typeface="Segoe UI Emoji"/>
+              </a:defRPr>
+            </a:pPr>
+            <a:r>
+              <a:t>✨</a:t>
             </a:r>
           </a:p>
         </p:txBody>

</xml_diff>